<commit_message>
docs: rebuild Power BI presentation with hybrid cards theme, slide transitions, and embedded screenshots
</commit_message>
<xml_diff>
--- a/Bus Booking Analytics System (PowerBI)/documents/Bus_Booking_Analytics_PowerBI_light.pptx
+++ b/Bus Booking Analytics System (PowerBI)/documents/Bus_Booking_Analytics_PowerBI_light.pptx
@@ -18,6 +18,8 @@
     <p:sldId id="266" r:id="rId17"/>
     <p:sldId id="267" r:id="rId18"/>
     <p:sldId id="268" r:id="rId19"/>
+    <p:sldId id="269" r:id="rId20"/>
+    <p:sldId id="270" r:id="rId21"/>
   </p:sldIdLst>
   <p:sldSz cx="12188952" cy="6858000" type="screen4x3"/>
   <p:notesSz cx="6858000" cy="9144000"/>
@@ -3133,7 +3135,7 @@
             <a:pPr>
               <a:defRPr sz="1400" b="1">
                 <a:solidFill>
-                  <a:srgbClr val="4F46E5"/>
+                  <a:srgbClr val="2563EB"/>
                 </a:solidFill>
                 <a:latin typeface="Segoe UI"/>
               </a:defRPr>
@@ -3302,8 +3304,8 @@
         </p:nvSpPr>
         <p:spPr>
           <a:xfrm>
-            <a:off x="548640" y="457200"/>
-            <a:ext cx="1371600" cy="1097280"/>
+            <a:off x="548640" y="365760"/>
+            <a:ext cx="1371600" cy="822960"/>
           </a:xfrm>
           <a:prstGeom prst="rect">
             <a:avLst/>
@@ -3317,9 +3319,9 @@
           <a:lstStyle/>
           <a:p>
             <a:pPr>
-              <a:defRPr sz="3600" b="1">
-                <a:solidFill>
-                  <a:srgbClr val="4F46E5"/>
+              <a:defRPr sz="3800" b="1">
+                <a:solidFill>
+                  <a:srgbClr val="2563EB"/>
                 </a:solidFill>
                 <a:latin typeface="Segoe UI"/>
               </a:defRPr>
@@ -3338,7 +3340,7 @@
         </p:nvSpPr>
         <p:spPr>
           <a:xfrm>
-            <a:off x="548640" y="1417320"/>
+            <a:off x="548640" y="1280160"/>
             <a:ext cx="3657600" cy="36576"/>
           </a:xfrm>
           <a:prstGeom prst="rect">
@@ -3362,8 +3364,8 @@
         </p:nvSpPr>
         <p:spPr>
           <a:xfrm>
-            <a:off x="548640" y="1554480"/>
-            <a:ext cx="7315200" cy="640080"/>
+            <a:off x="548640" y="1417320"/>
+            <a:ext cx="8229600" cy="640080"/>
           </a:xfrm>
           <a:prstGeom prst="rect">
             <a:avLst/>
@@ -3385,7 +3387,7 @@
               </a:defRPr>
             </a:pPr>
             <a:r>
-              <a:t>Customer Profiles &amp; Cohort Retention</a:t>
+              <a:t>Customer Profiles &amp; Cohort Retention (Page 4)</a:t>
             </a:r>
           </a:p>
         </p:txBody>
@@ -3421,7 +3423,7 @@
               </a:defRPr>
             </a:pPr>
             <a:r>
-              <a:t>10 / 10</a:t>
+              <a:t>10 / 14</a:t>
             </a:r>
           </a:p>
         </p:txBody>
@@ -3454,13 +3456,13 @@
               </a:spcAft>
               <a:defRPr sz="1500" b="1">
                 <a:solidFill>
-                  <a:srgbClr val="4F46E5"/>
-                </a:solidFill>
-                <a:latin typeface="Segoe UI"/>
-              </a:defRPr>
-            </a:pPr>
-            <a:r>
-              <a:t>PAGE 4: COHORT LOYALTY &amp; BRACKETS</a:t>
+                  <a:srgbClr val="2563EB"/>
+                </a:solidFill>
+                <a:latin typeface="Segoe UI"/>
+              </a:defRPr>
+            </a:pPr>
+            <a:r>
+              <a:t>COHORT LOYALTY &amp; BRACKETS</a:t>
             </a:r>
           </a:p>
           <a:p>
@@ -3531,7 +3533,7 @@
       </p:sp>
       <p:pic>
         <p:nvPicPr>
-          <p:cNvPr id="7" name="Picture 6" descr="media__1784141762506.png"/>
+          <p:cNvPr id="7" name="Picture 6" descr="Screenshot 2026-07-16 005322.png"/>
           <p:cNvPicPr>
             <a:picLocks noChangeAspect="1"/>
           </p:cNvPicPr>
@@ -3599,8 +3601,8 @@
         </p:nvSpPr>
         <p:spPr>
           <a:xfrm>
-            <a:off x="548640" y="457200"/>
-            <a:ext cx="1371600" cy="1097280"/>
+            <a:off x="548640" y="365760"/>
+            <a:ext cx="1371600" cy="822960"/>
           </a:xfrm>
           <a:prstGeom prst="rect">
             <a:avLst/>
@@ -3614,9 +3616,9 @@
           <a:lstStyle/>
           <a:p>
             <a:pPr>
-              <a:defRPr sz="3600" b="1">
-                <a:solidFill>
-                  <a:srgbClr val="4F46E5"/>
+              <a:defRPr sz="3800" b="1">
+                <a:solidFill>
+                  <a:srgbClr val="2563EB"/>
                 </a:solidFill>
                 <a:latin typeface="Segoe UI"/>
               </a:defRPr>
@@ -3635,7 +3637,7 @@
         </p:nvSpPr>
         <p:spPr>
           <a:xfrm>
-            <a:off x="548640" y="1417320"/>
+            <a:off x="548640" y="1280160"/>
             <a:ext cx="3657600" cy="36576"/>
           </a:xfrm>
           <a:prstGeom prst="rect">
@@ -3659,8 +3661,8 @@
         </p:nvSpPr>
         <p:spPr>
           <a:xfrm>
-            <a:off x="548640" y="1554480"/>
-            <a:ext cx="7315200" cy="640080"/>
+            <a:off x="548640" y="1417320"/>
+            <a:ext cx="8229600" cy="640080"/>
           </a:xfrm>
           <a:prstGeom prst="rect">
             <a:avLst/>
@@ -3682,7 +3684,7 @@
               </a:defRPr>
             </a:pPr>
             <a:r>
-              <a:t>Fleet Utilization &amp; Seating Capacity</a:t>
+              <a:t>Fleet Utilization &amp; Seating Capacity (Page 5)</a:t>
             </a:r>
           </a:p>
         </p:txBody>
@@ -3718,7 +3720,7 @@
               </a:defRPr>
             </a:pPr>
             <a:r>
-              <a:t>11 / 10</a:t>
+              <a:t>11 / 14</a:t>
             </a:r>
           </a:p>
         </p:txBody>
@@ -3751,13 +3753,13 @@
               </a:spcAft>
               <a:defRPr sz="1500" b="1">
                 <a:solidFill>
-                  <a:srgbClr val="4F46E5"/>
-                </a:solidFill>
-                <a:latin typeface="Segoe UI"/>
-              </a:defRPr>
-            </a:pPr>
-            <a:r>
-              <a:t>PAGE 5: LOAD FACTORS &amp; ASSETS</a:t>
+                  <a:srgbClr val="2563EB"/>
+                </a:solidFill>
+                <a:latin typeface="Segoe UI"/>
+              </a:defRPr>
+            </a:pPr>
+            <a:r>
+              <a:t>LOAD FACTORS &amp; ASSETS</a:t>
             </a:r>
           </a:p>
           <a:p>
@@ -3828,7 +3830,7 @@
       </p:sp>
       <p:pic>
         <p:nvPicPr>
-          <p:cNvPr id="7" name="Picture 6" descr="media__1784141792242.png"/>
+          <p:cNvPr id="7" name="Picture 6" descr="Screenshot 2026-07-16 005337.png"/>
           <p:cNvPicPr>
             <a:picLocks noChangeAspect="1"/>
           </p:cNvPicPr>
@@ -3896,8 +3898,8 @@
         </p:nvSpPr>
         <p:spPr>
           <a:xfrm>
-            <a:off x="548640" y="457200"/>
-            <a:ext cx="1371600" cy="1097280"/>
+            <a:off x="548640" y="365760"/>
+            <a:ext cx="1371600" cy="822960"/>
           </a:xfrm>
           <a:prstGeom prst="rect">
             <a:avLst/>
@@ -3911,9 +3913,9 @@
           <a:lstStyle/>
           <a:p>
             <a:pPr>
-              <a:defRPr sz="3600" b="1">
-                <a:solidFill>
-                  <a:srgbClr val="4F46E5"/>
+              <a:defRPr sz="3800" b="1">
+                <a:solidFill>
+                  <a:srgbClr val="2563EB"/>
                 </a:solidFill>
                 <a:latin typeface="Segoe UI"/>
               </a:defRPr>
@@ -3932,7 +3934,7 @@
         </p:nvSpPr>
         <p:spPr>
           <a:xfrm>
-            <a:off x="548640" y="1417320"/>
+            <a:off x="548640" y="1280160"/>
             <a:ext cx="3657600" cy="36576"/>
           </a:xfrm>
           <a:prstGeom prst="rect">
@@ -3956,8 +3958,8 @@
         </p:nvSpPr>
         <p:spPr>
           <a:xfrm>
-            <a:off x="548640" y="1554480"/>
-            <a:ext cx="7315200" cy="640080"/>
+            <a:off x="548640" y="1417320"/>
+            <a:ext cx="8229600" cy="640080"/>
           </a:xfrm>
           <a:prstGeom prst="rect">
             <a:avLst/>
@@ -3979,7 +3981,7 @@
               </a:defRPr>
             </a:pPr>
             <a:r>
-              <a:t>Strategic Recommendations</a:t>
+              <a:t>Route Performance &amp; Market Demands (Page 6)</a:t>
             </a:r>
           </a:p>
         </p:txBody>
@@ -4015,7 +4017,7 @@
               </a:defRPr>
             </a:pPr>
             <a:r>
-              <a:t>12 / 10</a:t>
+              <a:t>12 / 14</a:t>
             </a:r>
           </a:p>
         </p:txBody>
@@ -4028,8 +4030,8 @@
         </p:nvSpPr>
         <p:spPr>
           <a:xfrm>
-            <a:off x="457200" y="2377440"/>
-            <a:ext cx="5303520" cy="1645920"/>
+            <a:off x="548640" y="2377440"/>
+            <a:ext cx="5303520" cy="3657600"/>
           </a:xfrm>
           <a:prstGeom prst="rect">
             <a:avLst/>
@@ -4044,21 +4046,24 @@
           <a:p>
             <a:pPr>
               <a:spcAft>
-                <a:spcPts val="600"/>
-              </a:spcAft>
-              <a:defRPr sz="1400" b="1">
-                <a:solidFill>
-                  <a:srgbClr val="4F46E5"/>
-                </a:solidFill>
-                <a:latin typeface="Segoe UI"/>
-              </a:defRPr>
-            </a:pPr>
-            <a:r>
-              <a:t>▪ 🎫 Pricing Managers</a:t>
-            </a:r>
-          </a:p>
-          <a:p>
-            <a:pPr>
+                <a:spcPts val="1500"/>
+              </a:spcAft>
+              <a:defRPr sz="1500" b="1">
+                <a:solidFill>
+                  <a:srgbClr val="2563EB"/>
+                </a:solidFill>
+                <a:latin typeface="Segoe UI"/>
+              </a:defRPr>
+            </a:pPr>
+            <a:r>
+              <a:t>PASSENGER CORRIDORS &amp; VOLUMES</a:t>
+            </a:r>
+          </a:p>
+          <a:p>
+            <a:pPr>
+              <a:spcAft>
+                <a:spcPts val="1200"/>
+              </a:spcAft>
               <a:defRPr sz="1150">
                 <a:solidFill>
                   <a:srgbClr val="334155"/>
@@ -4067,167 +4072,83 @@
               </a:defRPr>
             </a:pPr>
             <a:r>
-              <a:t>Leverage dynamic pricing during May-June peaks. Elevate AC Sleeper rates by 10% on high-demand weekends to capture maximum yield.</a:t>
-            </a:r>
-          </a:p>
-        </p:txBody>
-      </p:sp>
-      <p:sp>
-        <p:nvSpPr>
-          <p:cNvPr id="7" name="TextBox 6"/>
-          <p:cNvSpPr txBox="1"/>
-          <p:nvPr/>
-        </p:nvSpPr>
-        <p:spPr>
-          <a:xfrm>
-            <a:off x="6217920" y="2377440"/>
-            <a:ext cx="5303520" cy="1645920"/>
+              <a:t>◆  Monitors city-to-city commuter traffic flows across active routes.</a:t>
+            </a:r>
+          </a:p>
+          <a:p>
+            <a:pPr>
+              <a:spcAft>
+                <a:spcPts val="1200"/>
+              </a:spcAft>
+              <a:defRPr sz="1150">
+                <a:solidFill>
+                  <a:srgbClr val="334155"/>
+                </a:solidFill>
+                <a:latin typeface="Segoe UI"/>
+              </a:defRPr>
+            </a:pPr>
+            <a:r>
+              <a:t>◆  High-density routes like Mumbai-Ahmedabad and Bangalore-Hyderabad represent peak revenue generators.</a:t>
+            </a:r>
+          </a:p>
+          <a:p>
+            <a:pPr>
+              <a:spcAft>
+                <a:spcPts val="1200"/>
+              </a:spcAft>
+              <a:defRPr sz="1150">
+                <a:solidFill>
+                  <a:srgbClr val="334155"/>
+                </a:solidFill>
+                <a:latin typeface="Segoe UI"/>
+              </a:defRPr>
+            </a:pPr>
+            <a:r>
+              <a:t>◆  Average distance traveled scales cleanly with revenue per seat run.</a:t>
+            </a:r>
+          </a:p>
+          <a:p>
+            <a:pPr>
+              <a:spcAft>
+                <a:spcPts val="1200"/>
+              </a:spcAft>
+              <a:defRPr sz="1150">
+                <a:solidFill>
+                  <a:srgbClr val="334155"/>
+                </a:solidFill>
+                <a:latin typeface="Segoe UI"/>
+              </a:defRPr>
+            </a:pPr>
+            <a:r>
+              <a:t>◆  Guides tactical route planning for vehicle redeployment.</a:t>
+            </a:r>
+          </a:p>
+        </p:txBody>
+      </p:sp>
+      <p:pic>
+        <p:nvPicPr>
+          <p:cNvPr id="7" name="Picture 6" descr="Screenshot 2026-07-16 005354.png"/>
+          <p:cNvPicPr>
+            <a:picLocks noChangeAspect="1"/>
+          </p:cNvPicPr>
+          <p:nvPr/>
+        </p:nvPicPr>
+        <p:blipFill>
+          <a:blip r:embed="rId2"/>
+          <a:stretch>
+            <a:fillRect/>
+          </a:stretch>
+        </p:blipFill>
+        <p:spPr>
+          <a:xfrm>
+            <a:off x="6217920" y="2286000"/>
+            <a:ext cx="5394960" cy="3035808"/>
           </a:xfrm>
           <a:prstGeom prst="rect">
             <a:avLst/>
           </a:prstGeom>
-          <a:noFill/>
-        </p:spPr>
-        <p:txBody>
-          <a:bodyPr wrap="square">
-            <a:spAutoFit/>
-          </a:bodyPr>
-          <a:lstStyle/>
-          <a:p>
-            <a:pPr>
-              <a:spcAft>
-                <a:spcPts val="600"/>
-              </a:spcAft>
-              <a:defRPr sz="1400" b="1">
-                <a:solidFill>
-                  <a:srgbClr val="4F46E5"/>
-                </a:solidFill>
-                <a:latin typeface="Segoe UI"/>
-              </a:defRPr>
-            </a:pPr>
-            <a:r>
-              <a:t>▪ 🚌 Dispatch Coordinators</a:t>
-            </a:r>
-          </a:p>
-          <a:p>
-            <a:pPr>
-              <a:defRPr sz="1150">
-                <a:solidFill>
-                  <a:srgbClr val="334155"/>
-                </a:solidFill>
-                <a:latin typeface="Segoe UI"/>
-              </a:defRPr>
-            </a:pPr>
-            <a:r>
-              <a:t>Improve the 51% fleet load factor. Consolidate low-occupancy weekday runs and reassign AC Seater buses to peak Bangalore/Delhi schedules.</a:t>
-            </a:r>
-          </a:p>
-        </p:txBody>
-      </p:sp>
-      <p:sp>
-        <p:nvSpPr>
-          <p:cNvPr id="8" name="TextBox 7"/>
-          <p:cNvSpPr txBox="1"/>
-          <p:nvPr/>
-        </p:nvSpPr>
-        <p:spPr>
-          <a:xfrm>
-            <a:off x="457200" y="4297680"/>
-            <a:ext cx="5303520" cy="1645920"/>
-          </a:xfrm>
-          <a:prstGeom prst="rect">
-            <a:avLst/>
-          </a:prstGeom>
-          <a:noFill/>
-        </p:spPr>
-        <p:txBody>
-          <a:bodyPr wrap="square">
-            <a:spAutoFit/>
-          </a:bodyPr>
-          <a:lstStyle/>
-          <a:p>
-            <a:pPr>
-              <a:spcAft>
-                <a:spcPts val="600"/>
-              </a:spcAft>
-              <a:defRPr sz="1400" b="1">
-                <a:solidFill>
-                  <a:srgbClr val="4F46E5"/>
-                </a:solidFill>
-                <a:latin typeface="Segoe UI"/>
-              </a:defRPr>
-            </a:pPr>
-            <a:r>
-              <a:t>▪ 📢 Marketing Specialists</a:t>
-            </a:r>
-          </a:p>
-          <a:p>
-            <a:pPr>
-              <a:defRPr sz="1150">
-                <a:solidFill>
-                  <a:srgbClr val="334155"/>
-                </a:solidFill>
-                <a:latin typeface="Segoe UI"/>
-              </a:defRPr>
-            </a:pPr>
-            <a:r>
-              <a:t>Launch targeted loyalty campaigns to boost retention past the 80% mark, focusing on the highly-profitable 25-45 age group bracket.</a:t>
-            </a:r>
-          </a:p>
-        </p:txBody>
-      </p:sp>
-      <p:sp>
-        <p:nvSpPr>
-          <p:cNvPr id="9" name="TextBox 8"/>
-          <p:cNvSpPr txBox="1"/>
-          <p:nvPr/>
-        </p:nvSpPr>
-        <p:spPr>
-          <a:xfrm>
-            <a:off x="6217920" y="4297680"/>
-            <a:ext cx="5303520" cy="1645920"/>
-          </a:xfrm>
-          <a:prstGeom prst="rect">
-            <a:avLst/>
-          </a:prstGeom>
-          <a:noFill/>
-        </p:spPr>
-        <p:txBody>
-          <a:bodyPr wrap="square">
-            <a:spAutoFit/>
-          </a:bodyPr>
-          <a:lstStyle/>
-          <a:p>
-            <a:pPr>
-              <a:spcAft>
-                <a:spcPts val="600"/>
-              </a:spcAft>
-              <a:defRPr sz="1400" b="1">
-                <a:solidFill>
-                  <a:srgbClr val="4F46E5"/>
-                </a:solidFill>
-                <a:latin typeface="Segoe UI"/>
-              </a:defRPr>
-            </a:pPr>
-            <a:r>
-              <a:t>▪ ⚙️ System Architects</a:t>
-            </a:r>
-          </a:p>
-          <a:p>
-            <a:pPr>
-              <a:defRPr sz="1150">
-                <a:solidFill>
-                  <a:srgbClr val="334155"/>
-                </a:solidFill>
-                <a:latin typeface="Segoe UI"/>
-              </a:defRPr>
-            </a:pPr>
-            <a:r>
-              <a:t>Preserve the MySQL relational schema for secure append runs. Protect local server config details inside separated configuration keys.</a:t>
-            </a:r>
-          </a:p>
-        </p:txBody>
-      </p:sp>
+        </p:spPr>
+      </p:pic>
     </p:spTree>
   </p:cSld>
   <mc:AlternateContent xmlns:mc="http://schemas.openxmlformats.org/markup-compatibility/2006">
@@ -4274,8 +4195,68 @@
         </p:nvSpPr>
         <p:spPr>
           <a:xfrm>
-            <a:off x="1828800" y="2468880"/>
-            <a:ext cx="8503920" cy="1371600"/>
+            <a:off x="548640" y="365760"/>
+            <a:ext cx="1371600" cy="822960"/>
+          </a:xfrm>
+          <a:prstGeom prst="rect">
+            <a:avLst/>
+          </a:prstGeom>
+          <a:noFill/>
+        </p:spPr>
+        <p:txBody>
+          <a:bodyPr wrap="none">
+            <a:spAutoFit/>
+          </a:bodyPr>
+          <a:lstStyle/>
+          <a:p>
+            <a:pPr>
+              <a:defRPr sz="3800" b="1">
+                <a:solidFill>
+                  <a:srgbClr val="2563EB"/>
+                </a:solidFill>
+                <a:latin typeface="Segoe UI"/>
+              </a:defRPr>
+            </a:pPr>
+            <a:r>
+              <a:t>12</a:t>
+            </a:r>
+          </a:p>
+        </p:txBody>
+      </p:sp>
+      <p:sp>
+        <p:nvSpPr>
+          <p:cNvPr id="3" name="TextBox 2"/>
+          <p:cNvSpPr txBox="1"/>
+          <p:nvPr/>
+        </p:nvSpPr>
+        <p:spPr>
+          <a:xfrm>
+            <a:off x="548640" y="1280160"/>
+            <a:ext cx="3657600" cy="36576"/>
+          </a:xfrm>
+          <a:prstGeom prst="rect">
+            <a:avLst/>
+          </a:prstGeom>
+          <a:noFill/>
+        </p:spPr>
+        <p:txBody>
+          <a:bodyPr wrap="none">
+            <a:spAutoFit/>
+          </a:bodyPr>
+          <a:lstStyle/>
+          <a:p/>
+        </p:txBody>
+      </p:sp>
+      <p:sp>
+        <p:nvSpPr>
+          <p:cNvPr id="4" name="TextBox 3"/>
+          <p:cNvSpPr txBox="1"/>
+          <p:nvPr/>
+        </p:nvSpPr>
+        <p:spPr>
+          <a:xfrm>
+            <a:off x="548640" y="1417320"/>
+            <a:ext cx="8229600" cy="640080"/>
           </a:xfrm>
           <a:prstGeom prst="rect">
             <a:avLst/>
@@ -4288,30 +4269,30 @@
           </a:bodyPr>
           <a:lstStyle/>
           <a:p>
-            <a:pPr algn="ctr">
-              <a:defRPr sz="4800" b="1">
-                <a:solidFill>
-                  <a:srgbClr val="4F46E5"/>
-                </a:solidFill>
-                <a:latin typeface="Segoe UI"/>
-              </a:defRPr>
-            </a:pPr>
-            <a:r>
-              <a:t>Thank You</a:t>
-            </a:r>
-          </a:p>
-        </p:txBody>
-      </p:sp>
-      <p:sp>
-        <p:nvSpPr>
-          <p:cNvPr id="3" name="TextBox 2"/>
+            <a:pPr>
+              <a:defRPr sz="2400" b="1">
+                <a:solidFill>
+                  <a:srgbClr val="0F172A"/>
+                </a:solidFill>
+                <a:latin typeface="Segoe UI"/>
+              </a:defRPr>
+            </a:pPr>
+            <a:r>
+              <a:t>Operational Reports &amp; Auditing (Page 7)</a:t>
+            </a:r>
+          </a:p>
+        </p:txBody>
+      </p:sp>
+      <p:sp>
+        <p:nvSpPr>
+          <p:cNvPr id="5" name="TextBox 4"/>
           <p:cNvSpPr txBox="1"/>
           <p:nvPr/>
         </p:nvSpPr>
         <p:spPr>
           <a:xfrm>
-            <a:off x="1828800" y="3840480"/>
-            <a:ext cx="8503920" cy="548640"/>
+            <a:off x="365760" y="6309360"/>
+            <a:ext cx="1371600" cy="365760"/>
           </a:xfrm>
           <a:prstGeom prst="rect">
             <a:avLst/>
@@ -4324,30 +4305,195 @@
           </a:bodyPr>
           <a:lstStyle/>
           <a:p>
-            <a:pPr algn="ctr">
-              <a:defRPr sz="1600" b="1">
-                <a:solidFill>
-                  <a:srgbClr val="0F172A"/>
-                </a:solidFill>
-                <a:latin typeface="Segoe UI"/>
-              </a:defRPr>
-            </a:pPr>
-            <a:r>
-              <a:t>Bus Booking Analytics System  |  Phase 2 Final Project</a:t>
-            </a:r>
-          </a:p>
-        </p:txBody>
-      </p:sp>
-      <p:sp>
-        <p:nvSpPr>
-          <p:cNvPr id="4" name="TextBox 3"/>
+            <a:pPr>
+              <a:defRPr sz="1100">
+                <a:solidFill>
+                  <a:srgbClr val="64748B"/>
+                </a:solidFill>
+                <a:latin typeface="Segoe UI"/>
+              </a:defRPr>
+            </a:pPr>
+            <a:r>
+              <a:t>13 / 14</a:t>
+            </a:r>
+          </a:p>
+        </p:txBody>
+      </p:sp>
+      <p:sp>
+        <p:nvSpPr>
+          <p:cNvPr id="6" name="TextBox 5"/>
           <p:cNvSpPr txBox="1"/>
           <p:nvPr/>
         </p:nvSpPr>
         <p:spPr>
           <a:xfrm>
-            <a:off x="1828800" y="4480560"/>
-            <a:ext cx="8503920" cy="822960"/>
+            <a:off x="548640" y="2377440"/>
+            <a:ext cx="5303520" cy="3657600"/>
+          </a:xfrm>
+          <a:prstGeom prst="rect">
+            <a:avLst/>
+          </a:prstGeom>
+          <a:noFill/>
+        </p:spPr>
+        <p:txBody>
+          <a:bodyPr wrap="square">
+            <a:spAutoFit/>
+          </a:bodyPr>
+          <a:lstStyle/>
+          <a:p>
+            <a:pPr>
+              <a:spcAft>
+                <a:spcPts val="1500"/>
+              </a:spcAft>
+              <a:defRPr sz="1500" b="1">
+                <a:solidFill>
+                  <a:srgbClr val="2563EB"/>
+                </a:solidFill>
+                <a:latin typeface="Segoe UI"/>
+              </a:defRPr>
+            </a:pPr>
+            <a:r>
+              <a:t>AUDIT RECORDS &amp; EXPORTS</a:t>
+            </a:r>
+          </a:p>
+          <a:p>
+            <a:pPr>
+              <a:spcAft>
+                <a:spcPts val="1200"/>
+              </a:spcAft>
+              <a:defRPr sz="1150">
+                <a:solidFill>
+                  <a:srgbClr val="334155"/>
+                </a:solidFill>
+                <a:latin typeface="Segoe UI"/>
+              </a:defRPr>
+            </a:pPr>
+            <a:r>
+              <a:t>◆  Granular transaction tables list exact passenger rows.</a:t>
+            </a:r>
+          </a:p>
+          <a:p>
+            <a:pPr>
+              <a:spcAft>
+                <a:spcPts val="1200"/>
+              </a:spcAft>
+              <a:defRPr sz="1150">
+                <a:solidFill>
+                  <a:srgbClr val="334155"/>
+                </a:solidFill>
+                <a:latin typeface="Segoe UI"/>
+              </a:defRPr>
+            </a:pPr>
+            <a:r>
+              <a:t>◆  Integrated dynamic search bars look up booking IDs and customer details instantly.</a:t>
+            </a:r>
+          </a:p>
+          <a:p>
+            <a:pPr>
+              <a:spcAft>
+                <a:spcPts val="1200"/>
+              </a:spcAft>
+              <a:defRPr sz="1150">
+                <a:solidFill>
+                  <a:srgbClr val="334155"/>
+                </a:solidFill>
+                <a:latin typeface="Segoe UI"/>
+              </a:defRPr>
+            </a:pPr>
+            <a:r>
+              <a:t>◆  Supports direct CSV table exports for spreadsheet calculations.</a:t>
+            </a:r>
+          </a:p>
+          <a:p>
+            <a:pPr>
+              <a:spcAft>
+                <a:spcPts val="1200"/>
+              </a:spcAft>
+              <a:defRPr sz="1150">
+                <a:solidFill>
+                  <a:srgbClr val="334155"/>
+                </a:solidFill>
+                <a:latin typeface="Segoe UI"/>
+              </a:defRPr>
+            </a:pPr>
+            <a:r>
+              <a:t>◆  Formatted alternating rows improve visual scannability.</a:t>
+            </a:r>
+          </a:p>
+        </p:txBody>
+      </p:sp>
+      <p:pic>
+        <p:nvPicPr>
+          <p:cNvPr id="7" name="Picture 6" descr="Screenshot 2026-07-16 005410.png"/>
+          <p:cNvPicPr>
+            <a:picLocks noChangeAspect="1"/>
+          </p:cNvPicPr>
+          <p:nvPr/>
+        </p:nvPicPr>
+        <p:blipFill>
+          <a:blip r:embed="rId2"/>
+          <a:stretch>
+            <a:fillRect/>
+          </a:stretch>
+        </p:blipFill>
+        <p:spPr>
+          <a:xfrm>
+            <a:off x="6217920" y="2286000"/>
+            <a:ext cx="5394960" cy="3035808"/>
+          </a:xfrm>
+          <a:prstGeom prst="rect">
+            <a:avLst/>
+          </a:prstGeom>
+        </p:spPr>
+      </p:pic>
+    </p:spTree>
+  </p:cSld>
+  <mc:AlternateContent xmlns:mc="http://schemas.openxmlformats.org/markup-compatibility/2006">
+    <mc:Choice xmlns:p14="http://schemas.microsoft.com/office/powerpoint/2010/main" Requires="p14">
+      <p:transition spd="slow">
+        <p:fade/>
+      </p:transition>
+    </mc:Choice>
+    <mc:Fallback>
+      <p:transition spd="slow">
+        <p:fade/>
+      </p:transition>
+    </mc:Fallback>
+  </mc:AlternateContent>
+  <p:clrMapOvr>
+    <a:masterClrMapping/>
+  </p:clrMapOvr>
+</p:sld>
+</file>
+
+<file path=ppt/slides/slide14.xml><?xml version="1.0" encoding="utf-8"?>
+<p:sld xmlns:a="http://schemas.openxmlformats.org/drawingml/2006/main" xmlns:p="http://schemas.openxmlformats.org/presentationml/2006/main" xmlns:r="http://schemas.openxmlformats.org/officeDocument/2006/relationships">
+  <p:cSld>
+    <p:bg>
+      <p:bgPr>
+        <a:solidFill>
+          <a:srgbClr val="FFFFFF"/>
+        </a:solidFill>
+        <a:effectLst/>
+      </p:bgPr>
+    </p:bg>
+    <p:spTree>
+      <p:nvGrpSpPr>
+        <p:cNvPr id="1" name=""/>
+        <p:cNvGrpSpPr/>
+        <p:nvPr/>
+      </p:nvGrpSpPr>
+      <p:grpSpPr/>
+      <p:sp>
+        <p:nvSpPr>
+          <p:cNvPr id="2" name="TextBox 1"/>
+          <p:cNvSpPr txBox="1"/>
+          <p:nvPr/>
+        </p:nvSpPr>
+        <p:spPr>
+          <a:xfrm>
+            <a:off x="548640" y="365760"/>
+            <a:ext cx="1371600" cy="822960"/>
           </a:xfrm>
           <a:prstGeom prst="rect">
             <a:avLst/>
@@ -4360,20 +4506,400 @@
           </a:bodyPr>
           <a:lstStyle/>
           <a:p>
+            <a:pPr>
+              <a:defRPr sz="3800" b="1">
+                <a:solidFill>
+                  <a:srgbClr val="2563EB"/>
+                </a:solidFill>
+                <a:latin typeface="Segoe UI"/>
+              </a:defRPr>
+            </a:pPr>
+            <a:r>
+              <a:t>13</a:t>
+            </a:r>
+          </a:p>
+        </p:txBody>
+      </p:sp>
+      <p:sp>
+        <p:nvSpPr>
+          <p:cNvPr id="3" name="TextBox 2"/>
+          <p:cNvSpPr txBox="1"/>
+          <p:nvPr/>
+        </p:nvSpPr>
+        <p:spPr>
+          <a:xfrm>
+            <a:off x="548640" y="1280160"/>
+            <a:ext cx="3657600" cy="36576"/>
+          </a:xfrm>
+          <a:prstGeom prst="rect">
+            <a:avLst/>
+          </a:prstGeom>
+          <a:noFill/>
+        </p:spPr>
+        <p:txBody>
+          <a:bodyPr wrap="none">
+            <a:spAutoFit/>
+          </a:bodyPr>
+          <a:lstStyle/>
+          <a:p/>
+        </p:txBody>
+      </p:sp>
+      <p:sp>
+        <p:nvSpPr>
+          <p:cNvPr id="4" name="TextBox 3"/>
+          <p:cNvSpPr txBox="1"/>
+          <p:nvPr/>
+        </p:nvSpPr>
+        <p:spPr>
+          <a:xfrm>
+            <a:off x="548640" y="1417320"/>
+            <a:ext cx="8229600" cy="640080"/>
+          </a:xfrm>
+          <a:prstGeom prst="rect">
+            <a:avLst/>
+          </a:prstGeom>
+          <a:noFill/>
+        </p:spPr>
+        <p:txBody>
+          <a:bodyPr wrap="square">
+            <a:spAutoFit/>
+          </a:bodyPr>
+          <a:lstStyle/>
+          <a:p>
+            <a:pPr>
+              <a:defRPr sz="2400" b="1">
+                <a:solidFill>
+                  <a:srgbClr val="0F172A"/>
+                </a:solidFill>
+                <a:latin typeface="Segoe UI"/>
+              </a:defRPr>
+            </a:pPr>
+            <a:r>
+              <a:t>Strategic Recommendations</a:t>
+            </a:r>
+          </a:p>
+        </p:txBody>
+      </p:sp>
+      <p:sp>
+        <p:nvSpPr>
+          <p:cNvPr id="5" name="TextBox 4"/>
+          <p:cNvSpPr txBox="1"/>
+          <p:nvPr/>
+        </p:nvSpPr>
+        <p:spPr>
+          <a:xfrm>
+            <a:off x="365760" y="6309360"/>
+            <a:ext cx="1371600" cy="365760"/>
+          </a:xfrm>
+          <a:prstGeom prst="rect">
+            <a:avLst/>
+          </a:prstGeom>
+          <a:noFill/>
+        </p:spPr>
+        <p:txBody>
+          <a:bodyPr wrap="none">
+            <a:spAutoFit/>
+          </a:bodyPr>
+          <a:lstStyle/>
+          <a:p>
+            <a:pPr>
+              <a:defRPr sz="1100">
+                <a:solidFill>
+                  <a:srgbClr val="64748B"/>
+                </a:solidFill>
+                <a:latin typeface="Segoe UI"/>
+              </a:defRPr>
+            </a:pPr>
+            <a:r>
+              <a:t>14 / 14</a:t>
+            </a:r>
+          </a:p>
+        </p:txBody>
+      </p:sp>
+      <p:sp>
+        <p:nvSpPr>
+          <p:cNvPr id="6" name="Rounded Rectangle 5"/>
+          <p:cNvSpPr/>
+          <p:nvPr/>
+        </p:nvSpPr>
+        <p:spPr>
+          <a:xfrm>
+            <a:off x="457200" y="2377440"/>
+            <a:ext cx="5303520" cy="1645920"/>
+          </a:xfrm>
+          <a:prstGeom prst="roundRect">
+            <a:avLst/>
+          </a:prstGeom>
+          <a:solidFill>
+            <a:srgbClr val="1A152C"/>
+          </a:solidFill>
+          <a:ln>
+            <a:noFill/>
+          </a:ln>
+        </p:spPr>
+        <p:style>
+          <a:lnRef idx="1">
+            <a:schemeClr val="accent1"/>
+          </a:lnRef>
+          <a:fillRef idx="3">
+            <a:schemeClr val="accent1"/>
+          </a:fillRef>
+          <a:effectRef idx="2">
+            <a:schemeClr val="accent1"/>
+          </a:effectRef>
+          <a:fontRef idx="minor">
+            <a:schemeClr val="lt1"/>
+          </a:fontRef>
+        </p:style>
+        <p:txBody>
+          <a:bodyPr rtlCol="0" anchor="ctr" wrap="square" lIns="228600" tIns="228600" rIns="228600" bIns="228600"/>
+          <a:lstStyle/>
+          <a:p>
             <a:pPr algn="ctr">
-              <a:defRPr sz="1300">
-                <a:solidFill>
-                  <a:srgbClr val="64748B"/>
-                </a:solidFill>
-                <a:latin typeface="Segoe UI"/>
-              </a:defRPr>
-            </a:pPr>
-            <a:r>
-              <a:t>Gururaj Shetty  |  Revature Data Analytics</a:t>
-            </a:r>
-            <a:br/>
-            <a:r>
-              <a:t>Email: shettygururaj279@gmail.com  |  GitHub: SHETYGURU</a:t>
+              <a:spcAft>
+                <a:spcPts val="1400"/>
+              </a:spcAft>
+              <a:defRPr sz="1300" b="1">
+                <a:solidFill>
+                  <a:srgbClr val="2563EB"/>
+                </a:solidFill>
+                <a:latin typeface="Segoe UI"/>
+              </a:defRPr>
+            </a:pPr>
+            <a:r>
+              <a:t>🎫 Pricing Managers</a:t>
+            </a:r>
+          </a:p>
+          <a:p>
+            <a:pPr>
+              <a:spcAft>
+                <a:spcPts val="1000"/>
+              </a:spcAft>
+              <a:defRPr sz="1100">
+                <a:solidFill>
+                  <a:srgbClr val="FFFFFF"/>
+                </a:solidFill>
+                <a:latin typeface="Segoe UI"/>
+              </a:defRPr>
+            </a:pPr>
+            <a:r>
+              <a:t>◆  Leverage dynamic pricing during May-June peaks. Elevate AC Sleeper rates by 10% on high-demand weekends to capture maximum yield.</a:t>
+            </a:r>
+          </a:p>
+        </p:txBody>
+      </p:sp>
+      <p:sp>
+        <p:nvSpPr>
+          <p:cNvPr id="7" name="Rounded Rectangle 6"/>
+          <p:cNvSpPr/>
+          <p:nvPr/>
+        </p:nvSpPr>
+        <p:spPr>
+          <a:xfrm>
+            <a:off x="6217920" y="2377440"/>
+            <a:ext cx="5303520" cy="1645920"/>
+          </a:xfrm>
+          <a:prstGeom prst="roundRect">
+            <a:avLst/>
+          </a:prstGeom>
+          <a:solidFill>
+            <a:srgbClr val="1A152C"/>
+          </a:solidFill>
+          <a:ln>
+            <a:noFill/>
+          </a:ln>
+        </p:spPr>
+        <p:style>
+          <a:lnRef idx="1">
+            <a:schemeClr val="accent1"/>
+          </a:lnRef>
+          <a:fillRef idx="3">
+            <a:schemeClr val="accent1"/>
+          </a:fillRef>
+          <a:effectRef idx="2">
+            <a:schemeClr val="accent1"/>
+          </a:effectRef>
+          <a:fontRef idx="minor">
+            <a:schemeClr val="lt1"/>
+          </a:fontRef>
+        </p:style>
+        <p:txBody>
+          <a:bodyPr rtlCol="0" anchor="ctr" wrap="square" lIns="228600" tIns="228600" rIns="228600" bIns="228600"/>
+          <a:lstStyle/>
+          <a:p>
+            <a:pPr algn="ctr">
+              <a:spcAft>
+                <a:spcPts val="1400"/>
+              </a:spcAft>
+              <a:defRPr sz="1300" b="1">
+                <a:solidFill>
+                  <a:srgbClr val="2563EB"/>
+                </a:solidFill>
+                <a:latin typeface="Segoe UI"/>
+              </a:defRPr>
+            </a:pPr>
+            <a:r>
+              <a:t>🚌 Dispatch Coordinators</a:t>
+            </a:r>
+          </a:p>
+          <a:p>
+            <a:pPr>
+              <a:spcAft>
+                <a:spcPts val="1000"/>
+              </a:spcAft>
+              <a:defRPr sz="1100">
+                <a:solidFill>
+                  <a:srgbClr val="FFFFFF"/>
+                </a:solidFill>
+                <a:latin typeface="Segoe UI"/>
+              </a:defRPr>
+            </a:pPr>
+            <a:r>
+              <a:t>◆  Improve the 51% fleet load factor. Consolidate low-occupancy weekday runs and reassign AC Seater buses to peak Bangalore/Delhi schedules.</a:t>
+            </a:r>
+          </a:p>
+        </p:txBody>
+      </p:sp>
+      <p:sp>
+        <p:nvSpPr>
+          <p:cNvPr id="8" name="Rounded Rectangle 7"/>
+          <p:cNvSpPr/>
+          <p:nvPr/>
+        </p:nvSpPr>
+        <p:spPr>
+          <a:xfrm>
+            <a:off x="457200" y="4297680"/>
+            <a:ext cx="5303520" cy="1645920"/>
+          </a:xfrm>
+          <a:prstGeom prst="roundRect">
+            <a:avLst/>
+          </a:prstGeom>
+          <a:solidFill>
+            <a:srgbClr val="1A152C"/>
+          </a:solidFill>
+          <a:ln>
+            <a:noFill/>
+          </a:ln>
+        </p:spPr>
+        <p:style>
+          <a:lnRef idx="1">
+            <a:schemeClr val="accent1"/>
+          </a:lnRef>
+          <a:fillRef idx="3">
+            <a:schemeClr val="accent1"/>
+          </a:fillRef>
+          <a:effectRef idx="2">
+            <a:schemeClr val="accent1"/>
+          </a:effectRef>
+          <a:fontRef idx="minor">
+            <a:schemeClr val="lt1"/>
+          </a:fontRef>
+        </p:style>
+        <p:txBody>
+          <a:bodyPr rtlCol="0" anchor="ctr" wrap="square" lIns="228600" tIns="228600" rIns="228600" bIns="228600"/>
+          <a:lstStyle/>
+          <a:p>
+            <a:pPr algn="ctr">
+              <a:spcAft>
+                <a:spcPts val="1400"/>
+              </a:spcAft>
+              <a:defRPr sz="1300" b="1">
+                <a:solidFill>
+                  <a:srgbClr val="2563EB"/>
+                </a:solidFill>
+                <a:latin typeface="Segoe UI"/>
+              </a:defRPr>
+            </a:pPr>
+            <a:r>
+              <a:t>📢 Marketing Specialists</a:t>
+            </a:r>
+          </a:p>
+          <a:p>
+            <a:pPr>
+              <a:spcAft>
+                <a:spcPts val="1000"/>
+              </a:spcAft>
+              <a:defRPr sz="1100">
+                <a:solidFill>
+                  <a:srgbClr val="FFFFFF"/>
+                </a:solidFill>
+                <a:latin typeface="Segoe UI"/>
+              </a:defRPr>
+            </a:pPr>
+            <a:r>
+              <a:t>◆  Launch targeted loyalty campaigns to boost retention past the 80% mark, focusing on the highly-profitable 25-45 age group bracket.</a:t>
+            </a:r>
+          </a:p>
+        </p:txBody>
+      </p:sp>
+      <p:sp>
+        <p:nvSpPr>
+          <p:cNvPr id="9" name="Rounded Rectangle 8"/>
+          <p:cNvSpPr/>
+          <p:nvPr/>
+        </p:nvSpPr>
+        <p:spPr>
+          <a:xfrm>
+            <a:off x="6217920" y="4297680"/>
+            <a:ext cx="5303520" cy="1645920"/>
+          </a:xfrm>
+          <a:prstGeom prst="roundRect">
+            <a:avLst/>
+          </a:prstGeom>
+          <a:solidFill>
+            <a:srgbClr val="1A152C"/>
+          </a:solidFill>
+          <a:ln>
+            <a:noFill/>
+          </a:ln>
+        </p:spPr>
+        <p:style>
+          <a:lnRef idx="1">
+            <a:schemeClr val="accent1"/>
+          </a:lnRef>
+          <a:fillRef idx="3">
+            <a:schemeClr val="accent1"/>
+          </a:fillRef>
+          <a:effectRef idx="2">
+            <a:schemeClr val="accent1"/>
+          </a:effectRef>
+          <a:fontRef idx="minor">
+            <a:schemeClr val="lt1"/>
+          </a:fontRef>
+        </p:style>
+        <p:txBody>
+          <a:bodyPr rtlCol="0" anchor="ctr" wrap="square" lIns="228600" tIns="228600" rIns="228600" bIns="228600"/>
+          <a:lstStyle/>
+          <a:p>
+            <a:pPr algn="ctr">
+              <a:spcAft>
+                <a:spcPts val="1400"/>
+              </a:spcAft>
+              <a:defRPr sz="1300" b="1">
+                <a:solidFill>
+                  <a:srgbClr val="2563EB"/>
+                </a:solidFill>
+                <a:latin typeface="Segoe UI"/>
+              </a:defRPr>
+            </a:pPr>
+            <a:r>
+              <a:t>⚙️ System Architects</a:t>
+            </a:r>
+          </a:p>
+          <a:p>
+            <a:pPr>
+              <a:spcAft>
+                <a:spcPts val="1000"/>
+              </a:spcAft>
+              <a:defRPr sz="1100">
+                <a:solidFill>
+                  <a:srgbClr val="FFFFFF"/>
+                </a:solidFill>
+                <a:latin typeface="Segoe UI"/>
+              </a:defRPr>
+            </a:pPr>
+            <a:r>
+              <a:t>◆  Preserve the MySQL relational schema for secure append runs. Protect local server config details inside separated configuration keys.</a:t>
             </a:r>
           </a:p>
         </p:txBody>
@@ -4389,6 +4915,156 @@
     <mc:Fallback>
       <p:transition spd="slow">
         <p:push dir="l"/>
+      </p:transition>
+    </mc:Fallback>
+  </mc:AlternateContent>
+  <p:clrMapOvr>
+    <a:masterClrMapping/>
+  </p:clrMapOvr>
+</p:sld>
+</file>
+
+<file path=ppt/slides/slide15.xml><?xml version="1.0" encoding="utf-8"?>
+<p:sld xmlns:a="http://schemas.openxmlformats.org/drawingml/2006/main" xmlns:p="http://schemas.openxmlformats.org/presentationml/2006/main" xmlns:r="http://schemas.openxmlformats.org/officeDocument/2006/relationships">
+  <p:cSld>
+    <p:bg>
+      <p:bgPr>
+        <a:solidFill>
+          <a:srgbClr val="FFFFFF"/>
+        </a:solidFill>
+        <a:effectLst/>
+      </p:bgPr>
+    </p:bg>
+    <p:spTree>
+      <p:nvGrpSpPr>
+        <p:cNvPr id="1" name=""/>
+        <p:cNvGrpSpPr/>
+        <p:nvPr/>
+      </p:nvGrpSpPr>
+      <p:grpSpPr/>
+      <p:sp>
+        <p:nvSpPr>
+          <p:cNvPr id="2" name="TextBox 1"/>
+          <p:cNvSpPr txBox="1"/>
+          <p:nvPr/>
+        </p:nvSpPr>
+        <p:spPr>
+          <a:xfrm>
+            <a:off x="1828800" y="2468880"/>
+            <a:ext cx="8503920" cy="1371600"/>
+          </a:xfrm>
+          <a:prstGeom prst="rect">
+            <a:avLst/>
+          </a:prstGeom>
+          <a:noFill/>
+        </p:spPr>
+        <p:txBody>
+          <a:bodyPr wrap="square">
+            <a:spAutoFit/>
+          </a:bodyPr>
+          <a:lstStyle/>
+          <a:p>
+            <a:pPr algn="ctr">
+              <a:defRPr sz="4800" b="1">
+                <a:solidFill>
+                  <a:srgbClr val="2563EB"/>
+                </a:solidFill>
+                <a:latin typeface="Segoe UI"/>
+              </a:defRPr>
+            </a:pPr>
+            <a:r>
+              <a:t>Thank You</a:t>
+            </a:r>
+          </a:p>
+        </p:txBody>
+      </p:sp>
+      <p:sp>
+        <p:nvSpPr>
+          <p:cNvPr id="3" name="TextBox 2"/>
+          <p:cNvSpPr txBox="1"/>
+          <p:nvPr/>
+        </p:nvSpPr>
+        <p:spPr>
+          <a:xfrm>
+            <a:off x="1828800" y="3840480"/>
+            <a:ext cx="8503920" cy="548640"/>
+          </a:xfrm>
+          <a:prstGeom prst="rect">
+            <a:avLst/>
+          </a:prstGeom>
+          <a:noFill/>
+        </p:spPr>
+        <p:txBody>
+          <a:bodyPr wrap="none">
+            <a:spAutoFit/>
+          </a:bodyPr>
+          <a:lstStyle/>
+          <a:p>
+            <a:pPr algn="ctr">
+              <a:defRPr sz="1600" b="1">
+                <a:solidFill>
+                  <a:srgbClr val="0F172A"/>
+                </a:solidFill>
+                <a:latin typeface="Segoe UI"/>
+              </a:defRPr>
+            </a:pPr>
+            <a:r>
+              <a:t>Bus Booking Analytics System  |  Phase 2 Final Project</a:t>
+            </a:r>
+          </a:p>
+        </p:txBody>
+      </p:sp>
+      <p:sp>
+        <p:nvSpPr>
+          <p:cNvPr id="4" name="TextBox 3"/>
+          <p:cNvSpPr txBox="1"/>
+          <p:nvPr/>
+        </p:nvSpPr>
+        <p:spPr>
+          <a:xfrm>
+            <a:off x="1828800" y="4480560"/>
+            <a:ext cx="8503920" cy="822960"/>
+          </a:xfrm>
+          <a:prstGeom prst="rect">
+            <a:avLst/>
+          </a:prstGeom>
+          <a:noFill/>
+        </p:spPr>
+        <p:txBody>
+          <a:bodyPr wrap="none">
+            <a:spAutoFit/>
+          </a:bodyPr>
+          <a:lstStyle/>
+          <a:p>
+            <a:pPr algn="ctr">
+              <a:defRPr sz="1300">
+                <a:solidFill>
+                  <a:srgbClr val="64748B"/>
+                </a:solidFill>
+                <a:latin typeface="Segoe UI"/>
+              </a:defRPr>
+            </a:pPr>
+            <a:r>
+              <a:t>Gururaj Shetty  |  Revature Data Analytics</a:t>
+            </a:r>
+            <a:br/>
+            <a:r>
+              <a:t>Email: shettygururaj279@gmail.com  |  GitHub: SHETYGURU</a:t>
+            </a:r>
+          </a:p>
+        </p:txBody>
+      </p:sp>
+    </p:spTree>
+  </p:cSld>
+  <mc:AlternateContent xmlns:mc="http://schemas.openxmlformats.org/markup-compatibility/2006">
+    <mc:Choice xmlns:p14="http://schemas.microsoft.com/office/powerpoint/2010/main" Requires="p14">
+      <p:transition spd="slow">
+        <p:fade/>
+      </p:transition>
+    </mc:Choice>
+    <mc:Fallback>
+      <p:transition spd="slow">
+        <p:fade/>
       </p:transition>
     </mc:Fallback>
   </mc:AlternateContent>
@@ -4424,8 +5100,8 @@
         </p:nvSpPr>
         <p:spPr>
           <a:xfrm>
-            <a:off x="548640" y="457200"/>
-            <a:ext cx="1371600" cy="1097280"/>
+            <a:off x="548640" y="365760"/>
+            <a:ext cx="1371600" cy="822960"/>
           </a:xfrm>
           <a:prstGeom prst="rect">
             <a:avLst/>
@@ -4439,9 +5115,9 @@
           <a:lstStyle/>
           <a:p>
             <a:pPr>
-              <a:defRPr sz="3600" b="1">
-                <a:solidFill>
-                  <a:srgbClr val="4F46E5"/>
+              <a:defRPr sz="3800" b="1">
+                <a:solidFill>
+                  <a:srgbClr val="2563EB"/>
                 </a:solidFill>
                 <a:latin typeface="Segoe UI"/>
               </a:defRPr>
@@ -4460,7 +5136,7 @@
         </p:nvSpPr>
         <p:spPr>
           <a:xfrm>
-            <a:off x="548640" y="1417320"/>
+            <a:off x="548640" y="1280160"/>
             <a:ext cx="3657600" cy="36576"/>
           </a:xfrm>
           <a:prstGeom prst="rect">
@@ -4484,8 +5160,8 @@
         </p:nvSpPr>
         <p:spPr>
           <a:xfrm>
-            <a:off x="548640" y="1554480"/>
-            <a:ext cx="7315200" cy="640080"/>
+            <a:off x="548640" y="1417320"/>
+            <a:ext cx="8229600" cy="640080"/>
           </a:xfrm>
           <a:prstGeom prst="rect">
             <a:avLst/>
@@ -4543,7 +5219,7 @@
               </a:defRPr>
             </a:pPr>
             <a:r>
-              <a:t>2 / 10</a:t>
+              <a:t>2 / 14</a:t>
             </a:r>
           </a:p>
         </p:txBody>
@@ -4729,8 +5405,8 @@
         </p:nvSpPr>
         <p:spPr>
           <a:xfrm>
-            <a:off x="548640" y="457200"/>
-            <a:ext cx="1371600" cy="1097280"/>
+            <a:off x="548640" y="365760"/>
+            <a:ext cx="1371600" cy="822960"/>
           </a:xfrm>
           <a:prstGeom prst="rect">
             <a:avLst/>
@@ -4744,9 +5420,9 @@
           <a:lstStyle/>
           <a:p>
             <a:pPr>
-              <a:defRPr sz="3600" b="1">
-                <a:solidFill>
-                  <a:srgbClr val="4F46E5"/>
+              <a:defRPr sz="3800" b="1">
+                <a:solidFill>
+                  <a:srgbClr val="2563EB"/>
                 </a:solidFill>
                 <a:latin typeface="Segoe UI"/>
               </a:defRPr>
@@ -4765,7 +5441,7 @@
         </p:nvSpPr>
         <p:spPr>
           <a:xfrm>
-            <a:off x="548640" y="1417320"/>
+            <a:off x="548640" y="1280160"/>
             <a:ext cx="3657600" cy="36576"/>
           </a:xfrm>
           <a:prstGeom prst="rect">
@@ -4789,8 +5465,8 @@
         </p:nvSpPr>
         <p:spPr>
           <a:xfrm>
-            <a:off x="548640" y="1554480"/>
-            <a:ext cx="7315200" cy="640080"/>
+            <a:off x="548640" y="1417320"/>
+            <a:ext cx="8229600" cy="640080"/>
           </a:xfrm>
           <a:prstGeom prst="rect">
             <a:avLst/>
@@ -4848,37 +5524,57 @@
               </a:defRPr>
             </a:pPr>
             <a:r>
-              <a:t>3 / 10</a:t>
-            </a:r>
-          </a:p>
-        </p:txBody>
-      </p:sp>
-      <p:sp>
-        <p:nvSpPr>
-          <p:cNvPr id="6" name="TextBox 5"/>
-          <p:cNvSpPr txBox="1"/>
+              <a:t>3 / 14</a:t>
+            </a:r>
+          </a:p>
+        </p:txBody>
+      </p:sp>
+      <p:sp>
+        <p:nvSpPr>
+          <p:cNvPr id="6" name="Rounded Rectangle 5"/>
+          <p:cNvSpPr/>
           <p:nvPr/>
         </p:nvSpPr>
         <p:spPr>
           <a:xfrm>
             <a:off x="548640" y="2468880"/>
-            <a:ext cx="3474720" cy="457200"/>
-          </a:xfrm>
-          <a:prstGeom prst="rect">
-            <a:avLst/>
-          </a:prstGeom>
-          <a:noFill/>
-        </p:spPr>
-        <p:txBody>
-          <a:bodyPr wrap="none">
-            <a:spAutoFit/>
-          </a:bodyPr>
-          <a:lstStyle/>
-          <a:p>
-            <a:pPr>
-              <a:defRPr sz="1500" b="1">
-                <a:solidFill>
-                  <a:srgbClr val="4F46E5"/>
+            <a:ext cx="3474720" cy="3657600"/>
+          </a:xfrm>
+          <a:prstGeom prst="roundRect">
+            <a:avLst/>
+          </a:prstGeom>
+          <a:solidFill>
+            <a:srgbClr val="1A152C"/>
+          </a:solidFill>
+          <a:ln>
+            <a:noFill/>
+          </a:ln>
+        </p:spPr>
+        <p:style>
+          <a:lnRef idx="1">
+            <a:schemeClr val="accent1"/>
+          </a:lnRef>
+          <a:fillRef idx="3">
+            <a:schemeClr val="accent1"/>
+          </a:fillRef>
+          <a:effectRef idx="2">
+            <a:schemeClr val="accent1"/>
+          </a:effectRef>
+          <a:fontRef idx="minor">
+            <a:schemeClr val="lt1"/>
+          </a:fontRef>
+        </p:style>
+        <p:txBody>
+          <a:bodyPr rtlCol="0" anchor="ctr" wrap="square" lIns="228600" tIns="228600" rIns="228600" bIns="228600"/>
+          <a:lstStyle/>
+          <a:p>
+            <a:pPr algn="ctr">
+              <a:spcAft>
+                <a:spcPts val="1400"/>
+              </a:spcAft>
+              <a:defRPr sz="1300" b="1">
+                <a:solidFill>
+                  <a:srgbClr val="EF4444"/>
                 </a:solidFill>
                 <a:latin typeface="Segoe UI"/>
               </a:defRPr>
@@ -4887,212 +5583,206 @@
               <a:t>⚡ THE PROBLEM</a:t>
             </a:r>
           </a:p>
-        </p:txBody>
-      </p:sp>
-      <p:sp>
-        <p:nvSpPr>
-          <p:cNvPr id="7" name="TextBox 6"/>
-          <p:cNvSpPr txBox="1"/>
-          <p:nvPr/>
-        </p:nvSpPr>
-        <p:spPr>
-          <a:xfrm>
-            <a:off x="548640" y="3017520"/>
-            <a:ext cx="3474720" cy="2926080"/>
-          </a:xfrm>
-          <a:prstGeom prst="rect">
-            <a:avLst/>
-          </a:prstGeom>
-          <a:noFill/>
-        </p:spPr>
-        <p:txBody>
-          <a:bodyPr wrap="square">
-            <a:spAutoFit/>
-          </a:bodyPr>
-          <a:lstStyle/>
-          <a:p>
-            <a:pPr>
-              <a:spcAft>
-                <a:spcPts val="1200"/>
-              </a:spcAft>
-              <a:defRPr sz="1200">
-                <a:solidFill>
-                  <a:srgbClr val="334155"/>
-                </a:solidFill>
-                <a:latin typeface="Segoe UI"/>
-              </a:defRPr>
-            </a:pPr>
-            <a:r>
-              <a:t>◆  Manual ticketing operations lack unified business reporting metrics</a:t>
-            </a:r>
-          </a:p>
-          <a:p>
-            <a:pPr>
-              <a:spcAft>
-                <a:spcPts val="1200"/>
-              </a:spcAft>
-              <a:defRPr sz="1200">
-                <a:solidFill>
-                  <a:srgbClr val="334155"/>
-                </a:solidFill>
-                <a:latin typeface="Segoe UI"/>
-              </a:defRPr>
-            </a:pPr>
-            <a:r>
-              <a:t>◆  Inconsistent data logs (duplicate IDs, unparseable dates) skew metrics</a:t>
-            </a:r>
-          </a:p>
-          <a:p>
-            <a:pPr>
-              <a:spcAft>
-                <a:spcPts val="1200"/>
-              </a:spcAft>
-              <a:defRPr sz="1200">
-                <a:solidFill>
-                  <a:srgbClr val="334155"/>
-                </a:solidFill>
-                <a:latin typeface="Segoe UI"/>
-              </a:defRPr>
-            </a:pPr>
-            <a:r>
-              <a:t>◆  Operations team lacks insights on asset yield and customer retention</a:t>
-            </a:r>
-          </a:p>
-        </p:txBody>
-      </p:sp>
-      <p:sp>
-        <p:nvSpPr>
-          <p:cNvPr id="8" name="TextBox 7"/>
-          <p:cNvSpPr txBox="1"/>
+          <a:p>
+            <a:pPr>
+              <a:spcAft>
+                <a:spcPts val="1000"/>
+              </a:spcAft>
+              <a:defRPr sz="1100">
+                <a:solidFill>
+                  <a:srgbClr val="FFFFFF"/>
+                </a:solidFill>
+                <a:latin typeface="Segoe UI"/>
+              </a:defRPr>
+            </a:pPr>
+            <a:r>
+              <a:t>◆  Studios risk millions greenlighting films with no data-backed insights</a:t>
+            </a:r>
+          </a:p>
+          <a:p>
+            <a:pPr>
+              <a:spcAft>
+                <a:spcPts val="1000"/>
+              </a:spcAft>
+              <a:defRPr sz="1100">
+                <a:solidFill>
+                  <a:srgbClr val="FFFFFF"/>
+                </a:solidFill>
+                <a:latin typeface="Segoe UI"/>
+              </a:defRPr>
+            </a:pPr>
+            <a:r>
+              <a:t>◆  Intuition-based decisions fail to predict ratings or revenue</a:t>
+            </a:r>
+          </a:p>
+          <a:p>
+            <a:pPr>
+              <a:spcAft>
+                <a:spcPts val="1000"/>
+              </a:spcAft>
+              <a:defRPr sz="1100">
+                <a:solidFill>
+                  <a:srgbClr val="FFFFFF"/>
+                </a:solidFill>
+                <a:latin typeface="Segoe UI"/>
+              </a:defRPr>
+            </a:pPr>
+            <a:r>
+              <a:t>◆  Raw unstructured data hides critical patterns and trends</a:t>
+            </a:r>
+          </a:p>
+        </p:txBody>
+      </p:sp>
+      <p:sp>
+        <p:nvSpPr>
+          <p:cNvPr id="7" name="Rounded Rectangle 6"/>
+          <p:cNvSpPr/>
           <p:nvPr/>
         </p:nvSpPr>
         <p:spPr>
           <a:xfrm>
             <a:off x="4297680" y="2468880"/>
-            <a:ext cx="3474720" cy="457200"/>
-          </a:xfrm>
-          <a:prstGeom prst="rect">
-            <a:avLst/>
-          </a:prstGeom>
-          <a:noFill/>
-        </p:spPr>
-        <p:txBody>
-          <a:bodyPr wrap="none">
-            <a:spAutoFit/>
-          </a:bodyPr>
-          <a:lstStyle/>
-          <a:p>
-            <a:pPr>
-              <a:defRPr sz="1500" b="1">
-                <a:solidFill>
-                  <a:srgbClr val="4F46E5"/>
-                </a:solidFill>
-                <a:latin typeface="Segoe UI"/>
-              </a:defRPr>
-            </a:pPr>
-            <a:r>
-              <a:t>✅ OUR SOLUTION</a:t>
-            </a:r>
-          </a:p>
-        </p:txBody>
-      </p:sp>
-      <p:sp>
-        <p:nvSpPr>
-          <p:cNvPr id="9" name="TextBox 8"/>
-          <p:cNvSpPr txBox="1"/>
-          <p:nvPr/>
-        </p:nvSpPr>
-        <p:spPr>
-          <a:xfrm>
-            <a:off x="4297680" y="3017520"/>
-            <a:ext cx="3474720" cy="2926080"/>
-          </a:xfrm>
-          <a:prstGeom prst="rect">
-            <a:avLst/>
-          </a:prstGeom>
-          <a:noFill/>
-        </p:spPr>
-        <p:txBody>
-          <a:bodyPr wrap="square">
-            <a:spAutoFit/>
-          </a:bodyPr>
-          <a:lstStyle/>
-          <a:p>
-            <a:pPr>
-              <a:spcAft>
-                <a:spcPts val="1200"/>
-              </a:spcAft>
-              <a:defRPr sz="1200">
-                <a:solidFill>
-                  <a:srgbClr val="334155"/>
-                </a:solidFill>
-                <a:latin typeface="Segoe UI"/>
-              </a:defRPr>
-            </a:pPr>
-            <a:r>
-              <a:t>◆  Standardize mixed date formats and deduplicate transaction lists</a:t>
-            </a:r>
-          </a:p>
-          <a:p>
-            <a:pPr>
-              <a:spcAft>
-                <a:spcPts val="1200"/>
-              </a:spcAft>
-              <a:defRPr sz="1200">
-                <a:solidFill>
-                  <a:srgbClr val="334155"/>
-                </a:solidFill>
-                <a:latin typeface="Segoe UI"/>
-              </a:defRPr>
-            </a:pPr>
-            <a:r>
-              <a:t>◆  Build relational MySQL schema enforcing reference key integrity</a:t>
-            </a:r>
-          </a:p>
-          <a:p>
-            <a:pPr>
-              <a:spcAft>
-                <a:spcPts val="1200"/>
-              </a:spcAft>
-              <a:defRPr sz="1200">
-                <a:solidFill>
-                  <a:srgbClr val="334155"/>
-                </a:solidFill>
-                <a:latin typeface="Segoe UI"/>
-              </a:defRPr>
-            </a:pPr>
-            <a:r>
-              <a:t>◆  Establish analytical dashboard platforms in Power BI</a:t>
-            </a:r>
-          </a:p>
-        </p:txBody>
-      </p:sp>
-      <p:sp>
-        <p:nvSpPr>
-          <p:cNvPr id="10" name="TextBox 9"/>
-          <p:cNvSpPr txBox="1"/>
+            <a:ext cx="3474720" cy="3657600"/>
+          </a:xfrm>
+          <a:prstGeom prst="roundRect">
+            <a:avLst/>
+          </a:prstGeom>
+          <a:solidFill>
+            <a:srgbClr val="1A152C"/>
+          </a:solidFill>
+          <a:ln>
+            <a:noFill/>
+          </a:ln>
+        </p:spPr>
+        <p:style>
+          <a:lnRef idx="1">
+            <a:schemeClr val="accent1"/>
+          </a:lnRef>
+          <a:fillRef idx="3">
+            <a:schemeClr val="accent1"/>
+          </a:fillRef>
+          <a:effectRef idx="2">
+            <a:schemeClr val="accent1"/>
+          </a:effectRef>
+          <a:fontRef idx="minor">
+            <a:schemeClr val="lt1"/>
+          </a:fontRef>
+        </p:style>
+        <p:txBody>
+          <a:bodyPr rtlCol="0" anchor="ctr" wrap="square" lIns="228600" tIns="228600" rIns="228600" bIns="228600"/>
+          <a:lstStyle/>
+          <a:p>
+            <a:pPr algn="ctr">
+              <a:spcAft>
+                <a:spcPts val="1400"/>
+              </a:spcAft>
+              <a:defRPr sz="1300" b="1">
+                <a:solidFill>
+                  <a:srgbClr val="22C55E"/>
+                </a:solidFill>
+                <a:latin typeface="Segoe UI"/>
+              </a:defRPr>
+            </a:pPr>
+            <a:r>
+              <a:t>✓ OUR SOLUTION</a:t>
+            </a:r>
+          </a:p>
+          <a:p>
+            <a:pPr>
+              <a:spcAft>
+                <a:spcPts val="1000"/>
+              </a:spcAft>
+              <a:defRPr sz="1100">
+                <a:solidFill>
+                  <a:srgbClr val="FFFFFF"/>
+                </a:solidFill>
+                <a:latin typeface="Segoe UI"/>
+              </a:defRPr>
+            </a:pPr>
+            <a:r>
+              <a:t>◆  Clean &amp; preprocess 5,043-movie IMDB dataset with Python/Pandas</a:t>
+            </a:r>
+          </a:p>
+          <a:p>
+            <a:pPr>
+              <a:spcAft>
+                <a:spcPts val="1000"/>
+              </a:spcAft>
+              <a:defRPr sz="1100">
+                <a:solidFill>
+                  <a:srgbClr val="FFFFFF"/>
+                </a:solidFill>
+                <a:latin typeface="Segoe UI"/>
+              </a:defRPr>
+            </a:pPr>
+            <a:r>
+              <a:t>◆  Build normalized MySQL schema (3NF) with junction tables</a:t>
+            </a:r>
+          </a:p>
+          <a:p>
+            <a:pPr>
+              <a:spcAft>
+                <a:spcPts val="1000"/>
+              </a:spcAft>
+              <a:defRPr sz="1100">
+                <a:solidFill>
+                  <a:srgbClr val="FFFFFF"/>
+                </a:solidFill>
+                <a:latin typeface="Segoe UI"/>
+              </a:defRPr>
+            </a:pPr>
+            <a:r>
+              <a:t>◆  Create 7 interactive Plotly charts with real-time filtering</a:t>
+            </a:r>
+          </a:p>
+        </p:txBody>
+      </p:sp>
+      <p:sp>
+        <p:nvSpPr>
+          <p:cNvPr id="8" name="Rounded Rectangle 7"/>
+          <p:cNvSpPr/>
           <p:nvPr/>
         </p:nvSpPr>
         <p:spPr>
           <a:xfrm>
             <a:off x="8046720" y="2468880"/>
-            <a:ext cx="3474720" cy="457200"/>
-          </a:xfrm>
-          <a:prstGeom prst="rect">
-            <a:avLst/>
-          </a:prstGeom>
-          <a:noFill/>
-        </p:spPr>
-        <p:txBody>
-          <a:bodyPr wrap="none">
-            <a:spAutoFit/>
-          </a:bodyPr>
-          <a:lstStyle/>
-          <a:p>
-            <a:pPr>
-              <a:defRPr sz="1500" b="1">
-                <a:solidFill>
-                  <a:srgbClr val="4F46E5"/>
+            <a:ext cx="3474720" cy="3657600"/>
+          </a:xfrm>
+          <a:prstGeom prst="roundRect">
+            <a:avLst/>
+          </a:prstGeom>
+          <a:solidFill>
+            <a:srgbClr val="1A152C"/>
+          </a:solidFill>
+          <a:ln>
+            <a:noFill/>
+          </a:ln>
+        </p:spPr>
+        <p:style>
+          <a:lnRef idx="1">
+            <a:schemeClr val="accent1"/>
+          </a:lnRef>
+          <a:fillRef idx="3">
+            <a:schemeClr val="accent1"/>
+          </a:fillRef>
+          <a:effectRef idx="2">
+            <a:schemeClr val="accent1"/>
+          </a:effectRef>
+          <a:fontRef idx="minor">
+            <a:schemeClr val="lt1"/>
+          </a:fontRef>
+        </p:style>
+        <p:txBody>
+          <a:bodyPr rtlCol="0" anchor="ctr" wrap="square" lIns="228600" tIns="228600" rIns="228600" bIns="228600"/>
+          <a:lstStyle/>
+          <a:p>
+            <a:pPr algn="ctr">
+              <a:spcAft>
+                <a:spcPts val="1400"/>
+              </a:spcAft>
+              <a:defRPr sz="1300" b="1">
+                <a:solidFill>
+                  <a:srgbClr val="EAB308"/>
                 </a:solidFill>
                 <a:latin typeface="Segoe UI"/>
               </a:defRPr>
@@ -5101,75 +5791,52 @@
               <a:t>🎯 IMPACT</a:t>
             </a:r>
           </a:p>
-        </p:txBody>
-      </p:sp>
-      <p:sp>
-        <p:nvSpPr>
-          <p:cNvPr id="11" name="TextBox 10"/>
-          <p:cNvSpPr txBox="1"/>
-          <p:nvPr/>
-        </p:nvSpPr>
-        <p:spPr>
-          <a:xfrm>
-            <a:off x="8046720" y="3017520"/>
-            <a:ext cx="3474720" cy="2926080"/>
-          </a:xfrm>
-          <a:prstGeom prst="rect">
-            <a:avLst/>
-          </a:prstGeom>
-          <a:noFill/>
-        </p:spPr>
-        <p:txBody>
-          <a:bodyPr wrap="square">
-            <a:spAutoFit/>
-          </a:bodyPr>
-          <a:lstStyle/>
-          <a:p>
-            <a:pPr>
-              <a:spcAft>
-                <a:spcPts val="1200"/>
-              </a:spcAft>
-              <a:defRPr sz="1200">
-                <a:solidFill>
-                  <a:srgbClr val="334155"/>
-                </a:solidFill>
-                <a:latin typeface="Segoe UI"/>
-              </a:defRPr>
-            </a:pPr>
-            <a:r>
-              <a:t>◆  Instant clarity on fleet load factor and ticket sales performance</a:t>
-            </a:r>
-          </a:p>
-          <a:p>
-            <a:pPr>
-              <a:spcAft>
-                <a:spcPts val="1200"/>
-              </a:spcAft>
-              <a:defRPr sz="1200">
-                <a:solidFill>
-                  <a:srgbClr val="334155"/>
-                </a:solidFill>
-                <a:latin typeface="Segoe UI"/>
-              </a:defRPr>
-            </a:pPr>
-            <a:r>
-              <a:t>◆  Durable database structures support secure incremental loads</a:t>
-            </a:r>
-          </a:p>
-          <a:p>
-            <a:pPr>
-              <a:spcAft>
-                <a:spcPts val="1200"/>
-              </a:spcAft>
-              <a:defRPr sz="1200">
-                <a:solidFill>
-                  <a:srgbClr val="334155"/>
-                </a:solidFill>
-                <a:latin typeface="Segoe UI"/>
-              </a:defRPr>
-            </a:pPr>
-            <a:r>
-              <a:t>◆  Data-driven routing guides operational dispatch strategies</a:t>
+          <a:p>
+            <a:pPr>
+              <a:spcAft>
+                <a:spcPts val="1000"/>
+              </a:spcAft>
+              <a:defRPr sz="1100">
+                <a:solidFill>
+                  <a:srgbClr val="FFFFFF"/>
+                </a:solidFill>
+                <a:latin typeface="Segoe UI"/>
+              </a:defRPr>
+            </a:pPr>
+            <a:r>
+              <a:t>◆  Data-driven decisions reduce financial risk for studios</a:t>
+            </a:r>
+          </a:p>
+          <a:p>
+            <a:pPr>
+              <a:spcAft>
+                <a:spcPts val="1000"/>
+              </a:spcAft>
+              <a:defRPr sz="1100">
+                <a:solidFill>
+                  <a:srgbClr val="FFFFFF"/>
+                </a:solidFill>
+                <a:latin typeface="Segoe UI"/>
+              </a:defRPr>
+            </a:pPr>
+            <a:r>
+              <a:t>◆  Interactive dashboards enable on-the-fly business exploration</a:t>
+            </a:r>
+          </a:p>
+          <a:p>
+            <a:pPr>
+              <a:spcAft>
+                <a:spcPts val="1000"/>
+              </a:spcAft>
+              <a:defRPr sz="1100">
+                <a:solidFill>
+                  <a:srgbClr val="FFFFFF"/>
+                </a:solidFill>
+                <a:latin typeface="Segoe UI"/>
+              </a:defRPr>
+            </a:pPr>
+            <a:r>
+              <a:t>◆  Actionable genre &amp; director insights for stakeholders</a:t>
             </a:r>
           </a:p>
         </p:txBody>
@@ -5220,8 +5887,8 @@
         </p:nvSpPr>
         <p:spPr>
           <a:xfrm>
-            <a:off x="548640" y="457200"/>
-            <a:ext cx="1371600" cy="1097280"/>
+            <a:off x="548640" y="365760"/>
+            <a:ext cx="1371600" cy="822960"/>
           </a:xfrm>
           <a:prstGeom prst="rect">
             <a:avLst/>
@@ -5235,9 +5902,9 @@
           <a:lstStyle/>
           <a:p>
             <a:pPr>
-              <a:defRPr sz="3600" b="1">
-                <a:solidFill>
-                  <a:srgbClr val="4F46E5"/>
+              <a:defRPr sz="3800" b="1">
+                <a:solidFill>
+                  <a:srgbClr val="2563EB"/>
                 </a:solidFill>
                 <a:latin typeface="Segoe UI"/>
               </a:defRPr>
@@ -5256,7 +5923,7 @@
         </p:nvSpPr>
         <p:spPr>
           <a:xfrm>
-            <a:off x="548640" y="1417320"/>
+            <a:off x="548640" y="1280160"/>
             <a:ext cx="3657600" cy="36576"/>
           </a:xfrm>
           <a:prstGeom prst="rect">
@@ -5280,8 +5947,8 @@
         </p:nvSpPr>
         <p:spPr>
           <a:xfrm>
-            <a:off x="548640" y="1554480"/>
-            <a:ext cx="7315200" cy="640080"/>
+            <a:off x="548640" y="1417320"/>
+            <a:ext cx="8229600" cy="640080"/>
           </a:xfrm>
           <a:prstGeom prst="rect">
             <a:avLst/>
@@ -5339,37 +6006,57 @@
               </a:defRPr>
             </a:pPr>
             <a:r>
-              <a:t>4 / 10</a:t>
-            </a:r>
-          </a:p>
-        </p:txBody>
-      </p:sp>
-      <p:sp>
-        <p:nvSpPr>
-          <p:cNvPr id="6" name="TextBox 5"/>
-          <p:cNvSpPr txBox="1"/>
-          <p:nvPr/>
-        </p:nvSpPr>
-        <p:spPr>
-          <a:xfrm>
-            <a:off x="548640" y="2651760"/>
-            <a:ext cx="2560320" cy="457200"/>
-          </a:xfrm>
-          <a:prstGeom prst="rect">
-            <a:avLst/>
-          </a:prstGeom>
-          <a:noFill/>
-        </p:spPr>
-        <p:txBody>
-          <a:bodyPr wrap="none">
-            <a:spAutoFit/>
-          </a:bodyPr>
-          <a:lstStyle/>
-          <a:p>
-            <a:pPr>
-              <a:defRPr sz="1600" b="1">
-                <a:solidFill>
-                  <a:srgbClr val="4F46E5"/>
+              <a:t>4 / 14</a:t>
+            </a:r>
+          </a:p>
+        </p:txBody>
+      </p:sp>
+      <p:sp>
+        <p:nvSpPr>
+          <p:cNvPr id="6" name="Rounded Rectangle 5"/>
+          <p:cNvSpPr/>
+          <p:nvPr/>
+        </p:nvSpPr>
+        <p:spPr>
+          <a:xfrm>
+            <a:off x="548640" y="2560320"/>
+            <a:ext cx="2560320" cy="3383280"/>
+          </a:xfrm>
+          <a:prstGeom prst="roundRect">
+            <a:avLst/>
+          </a:prstGeom>
+          <a:solidFill>
+            <a:srgbClr val="1A152C"/>
+          </a:solidFill>
+          <a:ln>
+            <a:noFill/>
+          </a:ln>
+        </p:spPr>
+        <p:style>
+          <a:lnRef idx="1">
+            <a:schemeClr val="accent1"/>
+          </a:lnRef>
+          <a:fillRef idx="3">
+            <a:schemeClr val="accent1"/>
+          </a:fillRef>
+          <a:effectRef idx="2">
+            <a:schemeClr val="accent1"/>
+          </a:effectRef>
+          <a:fontRef idx="minor">
+            <a:schemeClr val="lt1"/>
+          </a:fontRef>
+        </p:style>
+        <p:txBody>
+          <a:bodyPr rtlCol="0" anchor="ctr" wrap="square" lIns="228600" tIns="228600" rIns="228600" bIns="228600"/>
+          <a:lstStyle/>
+          <a:p>
+            <a:pPr algn="ctr">
+              <a:spcAft>
+                <a:spcPts val="1400"/>
+              </a:spcAft>
+              <a:defRPr sz="1300" b="1">
+                <a:solidFill>
+                  <a:srgbClr val="2563EB"/>
                 </a:solidFill>
                 <a:latin typeface="Segoe UI"/>
               </a:defRPr>
@@ -5378,78 +6065,102 @@
               <a:t>Python 3</a:t>
             </a:r>
           </a:p>
-        </p:txBody>
-      </p:sp>
-      <p:sp>
-        <p:nvSpPr>
-          <p:cNvPr id="7" name="TextBox 6"/>
-          <p:cNvSpPr txBox="1"/>
-          <p:nvPr/>
-        </p:nvSpPr>
-        <p:spPr>
-          <a:xfrm>
-            <a:off x="548640" y="3291840"/>
-            <a:ext cx="2560320" cy="2286000"/>
-          </a:xfrm>
-          <a:prstGeom prst="rect">
-            <a:avLst/>
-          </a:prstGeom>
-          <a:noFill/>
-        </p:spPr>
-        <p:txBody>
-          <a:bodyPr wrap="square">
-            <a:spAutoFit/>
-          </a:bodyPr>
-          <a:lstStyle/>
-          <a:p>
-            <a:pPr>
-              <a:defRPr sz="1300">
-                <a:solidFill>
-                  <a:srgbClr val="334155"/>
-                </a:solidFill>
-                <a:latin typeface="Segoe UI"/>
-              </a:defRPr>
-            </a:pPr>
-            <a:r>
-              <a:t>Pandas, NumPy</a:t>
-            </a:r>
-            <a:br/>
-            <a:r>
-              <a:t>Core data processing</a:t>
-            </a:r>
-            <a:br/>
-            <a:r>
-              <a:t>&amp; validation engine</a:t>
-            </a:r>
-          </a:p>
-        </p:txBody>
-      </p:sp>
-      <p:sp>
-        <p:nvSpPr>
-          <p:cNvPr id="8" name="TextBox 7"/>
-          <p:cNvSpPr txBox="1"/>
-          <p:nvPr/>
-        </p:nvSpPr>
-        <p:spPr>
-          <a:xfrm>
-            <a:off x="3383280" y="2651760"/>
-            <a:ext cx="2560320" cy="457200"/>
-          </a:xfrm>
-          <a:prstGeom prst="rect">
-            <a:avLst/>
-          </a:prstGeom>
-          <a:noFill/>
-        </p:spPr>
-        <p:txBody>
-          <a:bodyPr wrap="none">
-            <a:spAutoFit/>
-          </a:bodyPr>
-          <a:lstStyle/>
-          <a:p>
-            <a:pPr>
-              <a:defRPr sz="1600" b="1">
-                <a:solidFill>
-                  <a:srgbClr val="4F46E5"/>
+          <a:p>
+            <a:pPr>
+              <a:spcAft>
+                <a:spcPts val="1000"/>
+              </a:spcAft>
+              <a:defRPr sz="1100">
+                <a:solidFill>
+                  <a:srgbClr val="FFFFFF"/>
+                </a:solidFill>
+                <a:latin typeface="Segoe UI"/>
+              </a:defRPr>
+            </a:pPr>
+            <a:r>
+              <a:t>◆  Pandas, NumPy libraries</a:t>
+            </a:r>
+          </a:p>
+          <a:p>
+            <a:pPr>
+              <a:spcAft>
+                <a:spcPts val="1000"/>
+              </a:spcAft>
+              <a:defRPr sz="1100">
+                <a:solidFill>
+                  <a:srgbClr val="FFFFFF"/>
+                </a:solidFill>
+                <a:latin typeface="Segoe UI"/>
+              </a:defRPr>
+            </a:pPr>
+            <a:r>
+              <a:t>◆  Core data cleaning engine</a:t>
+            </a:r>
+          </a:p>
+          <a:p>
+            <a:pPr>
+              <a:spcAft>
+                <a:spcPts val="1000"/>
+              </a:spcAft>
+              <a:defRPr sz="1100">
+                <a:solidFill>
+                  <a:srgbClr val="FFFFFF"/>
+                </a:solidFill>
+                <a:latin typeface="Segoe UI"/>
+              </a:defRPr>
+            </a:pPr>
+            <a:r>
+              <a:t>◆  Constraint verification</a:t>
+            </a:r>
+          </a:p>
+        </p:txBody>
+      </p:sp>
+      <p:sp>
+        <p:nvSpPr>
+          <p:cNvPr id="7" name="Rounded Rectangle 6"/>
+          <p:cNvSpPr/>
+          <p:nvPr/>
+        </p:nvSpPr>
+        <p:spPr>
+          <a:xfrm>
+            <a:off x="3383280" y="2560320"/>
+            <a:ext cx="2560320" cy="3383280"/>
+          </a:xfrm>
+          <a:prstGeom prst="roundRect">
+            <a:avLst/>
+          </a:prstGeom>
+          <a:solidFill>
+            <a:srgbClr val="1A152C"/>
+          </a:solidFill>
+          <a:ln>
+            <a:noFill/>
+          </a:ln>
+        </p:spPr>
+        <p:style>
+          <a:lnRef idx="1">
+            <a:schemeClr val="accent1"/>
+          </a:lnRef>
+          <a:fillRef idx="3">
+            <a:schemeClr val="accent1"/>
+          </a:fillRef>
+          <a:effectRef idx="2">
+            <a:schemeClr val="accent1"/>
+          </a:effectRef>
+          <a:fontRef idx="minor">
+            <a:schemeClr val="lt1"/>
+          </a:fontRef>
+        </p:style>
+        <p:txBody>
+          <a:bodyPr rtlCol="0" anchor="ctr" wrap="square" lIns="228600" tIns="228600" rIns="228600" bIns="228600"/>
+          <a:lstStyle/>
+          <a:p>
+            <a:pPr algn="ctr">
+              <a:spcAft>
+                <a:spcPts val="1400"/>
+              </a:spcAft>
+              <a:defRPr sz="1300" b="1">
+                <a:solidFill>
+                  <a:srgbClr val="2563EB"/>
                 </a:solidFill>
                 <a:latin typeface="Segoe UI"/>
               </a:defRPr>
@@ -5458,78 +6169,102 @@
               <a:t>MySQL</a:t>
             </a:r>
           </a:p>
-        </p:txBody>
-      </p:sp>
-      <p:sp>
-        <p:nvSpPr>
-          <p:cNvPr id="9" name="TextBox 8"/>
-          <p:cNvSpPr txBox="1"/>
-          <p:nvPr/>
-        </p:nvSpPr>
-        <p:spPr>
-          <a:xfrm>
-            <a:off x="3383280" y="3291840"/>
-            <a:ext cx="2560320" cy="2286000"/>
-          </a:xfrm>
-          <a:prstGeom prst="rect">
-            <a:avLst/>
-          </a:prstGeom>
-          <a:noFill/>
-        </p:spPr>
-        <p:txBody>
-          <a:bodyPr wrap="square">
-            <a:spAutoFit/>
-          </a:bodyPr>
-          <a:lstStyle/>
-          <a:p>
-            <a:pPr>
-              <a:defRPr sz="1300">
-                <a:solidFill>
-                  <a:srgbClr val="334155"/>
-                </a:solidFill>
-                <a:latin typeface="Segoe UI"/>
-              </a:defRPr>
-            </a:pPr>
-            <a:r>
-              <a:t>Relational Database</a:t>
-            </a:r>
-            <a:br/>
-            <a:r>
-              <a:t>Staged schemas</a:t>
-            </a:r>
-            <a:br/>
-            <a:r>
-              <a:t>Reference keys</a:t>
-            </a:r>
-          </a:p>
-        </p:txBody>
-      </p:sp>
-      <p:sp>
-        <p:nvSpPr>
-          <p:cNvPr id="10" name="TextBox 9"/>
-          <p:cNvSpPr txBox="1"/>
-          <p:nvPr/>
-        </p:nvSpPr>
-        <p:spPr>
-          <a:xfrm>
-            <a:off x="6217920" y="2651760"/>
-            <a:ext cx="2560320" cy="457200"/>
-          </a:xfrm>
-          <a:prstGeom prst="rect">
-            <a:avLst/>
-          </a:prstGeom>
-          <a:noFill/>
-        </p:spPr>
-        <p:txBody>
-          <a:bodyPr wrap="none">
-            <a:spAutoFit/>
-          </a:bodyPr>
-          <a:lstStyle/>
-          <a:p>
-            <a:pPr>
-              <a:defRPr sz="1600" b="1">
-                <a:solidFill>
-                  <a:srgbClr val="4F46E5"/>
+          <a:p>
+            <a:pPr>
+              <a:spcAft>
+                <a:spcPts val="1000"/>
+              </a:spcAft>
+              <a:defRPr sz="1100">
+                <a:solidFill>
+                  <a:srgbClr val="FFFFFF"/>
+                </a:solidFill>
+                <a:latin typeface="Segoe UI"/>
+              </a:defRPr>
+            </a:pPr>
+            <a:r>
+              <a:t>◆  Relational tables structure</a:t>
+            </a:r>
+          </a:p>
+          <a:p>
+            <a:pPr>
+              <a:spcAft>
+                <a:spcPts val="1000"/>
+              </a:spcAft>
+              <a:defRPr sz="1100">
+                <a:solidFill>
+                  <a:srgbClr val="FFFFFF"/>
+                </a:solidFill>
+                <a:latin typeface="Segoe UI"/>
+              </a:defRPr>
+            </a:pPr>
+            <a:r>
+              <a:t>◆  Durable staging keys</a:t>
+            </a:r>
+          </a:p>
+          <a:p>
+            <a:pPr>
+              <a:spcAft>
+                <a:spcPts val="1000"/>
+              </a:spcAft>
+              <a:defRPr sz="1100">
+                <a:solidFill>
+                  <a:srgbClr val="FFFFFF"/>
+                </a:solidFill>
+                <a:latin typeface="Segoe UI"/>
+              </a:defRPr>
+            </a:pPr>
+            <a:r>
+              <a:t>◆  Performance indexes</a:t>
+            </a:r>
+          </a:p>
+        </p:txBody>
+      </p:sp>
+      <p:sp>
+        <p:nvSpPr>
+          <p:cNvPr id="8" name="Rounded Rectangle 7"/>
+          <p:cNvSpPr/>
+          <p:nvPr/>
+        </p:nvSpPr>
+        <p:spPr>
+          <a:xfrm>
+            <a:off x="6217920" y="2560320"/>
+            <a:ext cx="2560320" cy="3383280"/>
+          </a:xfrm>
+          <a:prstGeom prst="roundRect">
+            <a:avLst/>
+          </a:prstGeom>
+          <a:solidFill>
+            <a:srgbClr val="1A152C"/>
+          </a:solidFill>
+          <a:ln>
+            <a:noFill/>
+          </a:ln>
+        </p:spPr>
+        <p:style>
+          <a:lnRef idx="1">
+            <a:schemeClr val="accent1"/>
+          </a:lnRef>
+          <a:fillRef idx="3">
+            <a:schemeClr val="accent1"/>
+          </a:fillRef>
+          <a:effectRef idx="2">
+            <a:schemeClr val="accent1"/>
+          </a:effectRef>
+          <a:fontRef idx="minor">
+            <a:schemeClr val="lt1"/>
+          </a:fontRef>
+        </p:style>
+        <p:txBody>
+          <a:bodyPr rtlCol="0" anchor="ctr" wrap="square" lIns="228600" tIns="228600" rIns="228600" bIns="228600"/>
+          <a:lstStyle/>
+          <a:p>
+            <a:pPr algn="ctr">
+              <a:spcAft>
+                <a:spcPts val="1400"/>
+              </a:spcAft>
+              <a:defRPr sz="1300" b="1">
+                <a:solidFill>
+                  <a:srgbClr val="2563EB"/>
                 </a:solidFill>
                 <a:latin typeface="Segoe UI"/>
               </a:defRPr>
@@ -5538,78 +6273,102 @@
               <a:t>Power BI</a:t>
             </a:r>
           </a:p>
-        </p:txBody>
-      </p:sp>
-      <p:sp>
-        <p:nvSpPr>
-          <p:cNvPr id="11" name="TextBox 10"/>
-          <p:cNvSpPr txBox="1"/>
-          <p:nvPr/>
-        </p:nvSpPr>
-        <p:spPr>
-          <a:xfrm>
-            <a:off x="6217920" y="3291840"/>
-            <a:ext cx="2560320" cy="2286000"/>
-          </a:xfrm>
-          <a:prstGeom prst="rect">
-            <a:avLst/>
-          </a:prstGeom>
-          <a:noFill/>
-        </p:spPr>
-        <p:txBody>
-          <a:bodyPr wrap="square">
-            <a:spAutoFit/>
-          </a:bodyPr>
-          <a:lstStyle/>
-          <a:p>
-            <a:pPr>
-              <a:defRPr sz="1300">
-                <a:solidFill>
-                  <a:srgbClr val="334155"/>
-                </a:solidFill>
-                <a:latin typeface="Segoe UI"/>
-              </a:defRPr>
-            </a:pPr>
-            <a:r>
-              <a:t>Corporate visualization</a:t>
-            </a:r>
-            <a:br/>
-            <a:r>
-              <a:t>Dynamic filter panels</a:t>
-            </a:r>
-            <a:br/>
-            <a:r>
-              <a:t>Dashboard reporting</a:t>
-            </a:r>
-          </a:p>
-        </p:txBody>
-      </p:sp>
-      <p:sp>
-        <p:nvSpPr>
-          <p:cNvPr id="12" name="TextBox 11"/>
-          <p:cNvSpPr txBox="1"/>
-          <p:nvPr/>
-        </p:nvSpPr>
-        <p:spPr>
-          <a:xfrm>
-            <a:off x="9052560" y="2651760"/>
-            <a:ext cx="2560320" cy="457200"/>
-          </a:xfrm>
-          <a:prstGeom prst="rect">
-            <a:avLst/>
-          </a:prstGeom>
-          <a:noFill/>
-        </p:spPr>
-        <p:txBody>
-          <a:bodyPr wrap="none">
-            <a:spAutoFit/>
-          </a:bodyPr>
-          <a:lstStyle/>
-          <a:p>
-            <a:pPr>
-              <a:defRPr sz="1600" b="1">
-                <a:solidFill>
-                  <a:srgbClr val="4F46E5"/>
+          <a:p>
+            <a:pPr>
+              <a:spcAft>
+                <a:spcPts val="1000"/>
+              </a:spcAft>
+              <a:defRPr sz="1100">
+                <a:solidFill>
+                  <a:srgbClr val="FFFFFF"/>
+                </a:solidFill>
+                <a:latin typeface="Segoe UI"/>
+              </a:defRPr>
+            </a:pPr>
+            <a:r>
+              <a:t>◆  Corporate data dashboards</a:t>
+            </a:r>
+          </a:p>
+          <a:p>
+            <a:pPr>
+              <a:spcAft>
+                <a:spcPts val="1000"/>
+              </a:spcAft>
+              <a:defRPr sz="1100">
+                <a:solidFill>
+                  <a:srgbClr val="FFFFFF"/>
+                </a:solidFill>
+                <a:latin typeface="Segoe UI"/>
+              </a:defRPr>
+            </a:pPr>
+            <a:r>
+              <a:t>◆  Dynamic slicer panels</a:t>
+            </a:r>
+          </a:p>
+          <a:p>
+            <a:pPr>
+              <a:spcAft>
+                <a:spcPts val="1000"/>
+              </a:spcAft>
+              <a:defRPr sz="1100">
+                <a:solidFill>
+                  <a:srgbClr val="FFFFFF"/>
+                </a:solidFill>
+                <a:latin typeface="Segoe UI"/>
+              </a:defRPr>
+            </a:pPr>
+            <a:r>
+              <a:t>◆  Executive summaries</a:t>
+            </a:r>
+          </a:p>
+        </p:txBody>
+      </p:sp>
+      <p:sp>
+        <p:nvSpPr>
+          <p:cNvPr id="9" name="Rounded Rectangle 8"/>
+          <p:cNvSpPr/>
+          <p:nvPr/>
+        </p:nvSpPr>
+        <p:spPr>
+          <a:xfrm>
+            <a:off x="9052560" y="2560320"/>
+            <a:ext cx="2560320" cy="3383280"/>
+          </a:xfrm>
+          <a:prstGeom prst="roundRect">
+            <a:avLst/>
+          </a:prstGeom>
+          <a:solidFill>
+            <a:srgbClr val="1A152C"/>
+          </a:solidFill>
+          <a:ln>
+            <a:noFill/>
+          </a:ln>
+        </p:spPr>
+        <p:style>
+          <a:lnRef idx="1">
+            <a:schemeClr val="accent1"/>
+          </a:lnRef>
+          <a:fillRef idx="3">
+            <a:schemeClr val="accent1"/>
+          </a:fillRef>
+          <a:effectRef idx="2">
+            <a:schemeClr val="accent1"/>
+          </a:effectRef>
+          <a:fontRef idx="minor">
+            <a:schemeClr val="lt1"/>
+          </a:fontRef>
+        </p:style>
+        <p:txBody>
+          <a:bodyPr rtlCol="0" anchor="ctr" wrap="square" lIns="228600" tIns="228600" rIns="228600" bIns="228600"/>
+          <a:lstStyle/>
+          <a:p>
+            <a:pPr algn="ctr">
+              <a:spcAft>
+                <a:spcPts val="1400"/>
+              </a:spcAft>
+              <a:defRPr sz="1300" b="1">
+                <a:solidFill>
+                  <a:srgbClr val="2563EB"/>
                 </a:solidFill>
                 <a:latin typeface="Segoe UI"/>
               </a:defRPr>
@@ -5618,48 +6377,52 @@
               <a:t>DAX &amp; PQ</a:t>
             </a:r>
           </a:p>
-        </p:txBody>
-      </p:sp>
-      <p:sp>
-        <p:nvSpPr>
-          <p:cNvPr id="13" name="TextBox 12"/>
-          <p:cNvSpPr txBox="1"/>
-          <p:nvPr/>
-        </p:nvSpPr>
-        <p:spPr>
-          <a:xfrm>
-            <a:off x="9052560" y="3291840"/>
-            <a:ext cx="2560320" cy="2286000"/>
-          </a:xfrm>
-          <a:prstGeom prst="rect">
-            <a:avLst/>
-          </a:prstGeom>
-          <a:noFill/>
-        </p:spPr>
-        <p:txBody>
-          <a:bodyPr wrap="square">
-            <a:spAutoFit/>
-          </a:bodyPr>
-          <a:lstStyle/>
-          <a:p>
-            <a:pPr>
-              <a:defRPr sz="1300">
-                <a:solidFill>
-                  <a:srgbClr val="334155"/>
-                </a:solidFill>
-                <a:latin typeface="Segoe UI"/>
-              </a:defRPr>
-            </a:pPr>
-            <a:r>
-              <a:t>Data modeling</a:t>
-            </a:r>
-            <a:br/>
-            <a:r>
-              <a:t>Power Query cleansing</a:t>
-            </a:r>
-            <a:br/>
-            <a:r>
-              <a:t>KPI measures</a:t>
+          <a:p>
+            <a:pPr>
+              <a:spcAft>
+                <a:spcPts val="1000"/>
+              </a:spcAft>
+              <a:defRPr sz="1100">
+                <a:solidFill>
+                  <a:srgbClr val="FFFFFF"/>
+                </a:solidFill>
+                <a:latin typeface="Segoe UI"/>
+              </a:defRPr>
+            </a:pPr>
+            <a:r>
+              <a:t>◆  Custom calculated measures</a:t>
+            </a:r>
+          </a:p>
+          <a:p>
+            <a:pPr>
+              <a:spcAft>
+                <a:spcPts val="1000"/>
+              </a:spcAft>
+              <a:defRPr sz="1100">
+                <a:solidFill>
+                  <a:srgbClr val="FFFFFF"/>
+                </a:solidFill>
+                <a:latin typeface="Segoe UI"/>
+              </a:defRPr>
+            </a:pPr>
+            <a:r>
+              <a:t>◆  Power Query pipelines</a:t>
+            </a:r>
+          </a:p>
+          <a:p>
+            <a:pPr>
+              <a:spcAft>
+                <a:spcPts val="1000"/>
+              </a:spcAft>
+              <a:defRPr sz="1100">
+                <a:solidFill>
+                  <a:srgbClr val="FFFFFF"/>
+                </a:solidFill>
+                <a:latin typeface="Segoe UI"/>
+              </a:defRPr>
+            </a:pPr>
+            <a:r>
+              <a:t>◆  Star-schema modeling</a:t>
             </a:r>
           </a:p>
         </p:txBody>
@@ -5710,8 +6473,8 @@
         </p:nvSpPr>
         <p:spPr>
           <a:xfrm>
-            <a:off x="548640" y="457200"/>
-            <a:ext cx="1371600" cy="1097280"/>
+            <a:off x="548640" y="365760"/>
+            <a:ext cx="1371600" cy="822960"/>
           </a:xfrm>
           <a:prstGeom prst="rect">
             <a:avLst/>
@@ -5725,9 +6488,9 @@
           <a:lstStyle/>
           <a:p>
             <a:pPr>
-              <a:defRPr sz="3600" b="1">
-                <a:solidFill>
-                  <a:srgbClr val="4F46E5"/>
+              <a:defRPr sz="3800" b="1">
+                <a:solidFill>
+                  <a:srgbClr val="2563EB"/>
                 </a:solidFill>
                 <a:latin typeface="Segoe UI"/>
               </a:defRPr>
@@ -5746,7 +6509,7 @@
         </p:nvSpPr>
         <p:spPr>
           <a:xfrm>
-            <a:off x="548640" y="1417320"/>
+            <a:off x="548640" y="1280160"/>
             <a:ext cx="3657600" cy="36576"/>
           </a:xfrm>
           <a:prstGeom prst="rect">
@@ -5770,8 +6533,8 @@
         </p:nvSpPr>
         <p:spPr>
           <a:xfrm>
-            <a:off x="548640" y="1554480"/>
-            <a:ext cx="7315200" cy="640080"/>
+            <a:off x="548640" y="1417320"/>
+            <a:ext cx="8229600" cy="640080"/>
           </a:xfrm>
           <a:prstGeom prst="rect">
             <a:avLst/>
@@ -5829,7 +6592,7 @@
               </a:defRPr>
             </a:pPr>
             <a:r>
-              <a:t>5 / 10</a:t>
+              <a:t>5 / 14</a:t>
             </a:r>
           </a:p>
         </p:txBody>
@@ -5859,7 +6622,7 @@
             <a:pPr>
               <a:defRPr sz="1600" b="1">
                 <a:solidFill>
-                  <a:srgbClr val="4F46E5"/>
+                  <a:srgbClr val="2563EB"/>
                 </a:solidFill>
                 <a:latin typeface="Segoe UI"/>
               </a:defRPr>
@@ -5975,33 +6738,50 @@
       </p:sp>
       <p:sp>
         <p:nvSpPr>
-          <p:cNvPr id="8" name="TextBox 7"/>
-          <p:cNvSpPr txBox="1"/>
+          <p:cNvPr id="8" name="Rounded Rectangle 7"/>
+          <p:cNvSpPr/>
           <p:nvPr/>
         </p:nvSpPr>
         <p:spPr>
           <a:xfrm>
             <a:off x="6217920" y="2377440"/>
-            <a:ext cx="5303520" cy="3474720"/>
-          </a:xfrm>
-          <a:prstGeom prst="rect">
-            <a:avLst/>
-          </a:prstGeom>
-          <a:noFill/>
-        </p:spPr>
-        <p:txBody>
-          <a:bodyPr wrap="square">
-            <a:spAutoFit/>
-          </a:bodyPr>
-          <a:lstStyle/>
-          <a:p>
-            <a:pPr>
-              <a:spcAft>
-                <a:spcPts val="1500"/>
-              </a:spcAft>
-              <a:defRPr sz="1500" b="1">
-                <a:solidFill>
-                  <a:srgbClr val="4F46E5"/>
+            <a:ext cx="5303520" cy="3566160"/>
+          </a:xfrm>
+          <a:prstGeom prst="roundRect">
+            <a:avLst/>
+          </a:prstGeom>
+          <a:solidFill>
+            <a:srgbClr val="1A152C"/>
+          </a:solidFill>
+          <a:ln>
+            <a:noFill/>
+          </a:ln>
+        </p:spPr>
+        <p:style>
+          <a:lnRef idx="1">
+            <a:schemeClr val="accent1"/>
+          </a:lnRef>
+          <a:fillRef idx="3">
+            <a:schemeClr val="accent1"/>
+          </a:fillRef>
+          <a:effectRef idx="2">
+            <a:schemeClr val="accent1"/>
+          </a:effectRef>
+          <a:fontRef idx="minor">
+            <a:schemeClr val="lt1"/>
+          </a:fontRef>
+        </p:style>
+        <p:txBody>
+          <a:bodyPr rtlCol="0" anchor="ctr" wrap="square" lIns="228600" tIns="228600" rIns="228600" bIns="228600"/>
+          <a:lstStyle/>
+          <a:p>
+            <a:pPr algn="ctr">
+              <a:spcAft>
+                <a:spcPts val="1400"/>
+              </a:spcAft>
+              <a:defRPr sz="1300" b="1">
+                <a:solidFill>
+                  <a:srgbClr val="22C55E"/>
                 </a:solidFill>
                 <a:latin typeface="Segoe UI"/>
               </a:defRPr>
@@ -6012,137 +6792,82 @@
           </a:p>
           <a:p>
             <a:pPr>
-              <a:defRPr sz="1200" b="1">
-                <a:solidFill>
-                  <a:srgbClr val="334155"/>
-                </a:solidFill>
-              </a:defRPr>
-            </a:pPr>
-            <a:r>
-              <a:t>• Raw Input Volume:</a:t>
-            </a:r>
-          </a:p>
-          <a:p>
-            <a:pPr>
-              <a:spcAft>
-                <a:spcPts val="800"/>
+              <a:spcAft>
+                <a:spcPts val="1000"/>
               </a:spcAft>
               <a:defRPr sz="1100">
                 <a:solidFill>
-                  <a:srgbClr val="64748B"/>
-                </a:solidFill>
-              </a:defRPr>
-            </a:pPr>
-            <a:r>
-              <a:t>  11,848 booking records (dirty logs)</a:t>
-            </a:r>
-          </a:p>
-          <a:p>
-            <a:pPr>
-              <a:defRPr sz="1200" b="1">
-                <a:solidFill>
-                  <a:srgbClr val="334155"/>
-                </a:solidFill>
-              </a:defRPr>
-            </a:pPr>
-            <a:r>
-              <a:t>• Clean Output Volume:</a:t>
-            </a:r>
-          </a:p>
-          <a:p>
-            <a:pPr>
-              <a:spcAft>
-                <a:spcPts val="800"/>
+                  <a:srgbClr val="FFFFFF"/>
+                </a:solidFill>
+                <a:latin typeface="Segoe UI"/>
+              </a:defRPr>
+            </a:pPr>
+            <a:r>
+              <a:t>◆  Raw Input Volume: 11,848 booking records</a:t>
+            </a:r>
+          </a:p>
+          <a:p>
+            <a:pPr>
+              <a:spcAft>
+                <a:spcPts val="1000"/>
               </a:spcAft>
               <a:defRPr sz="1100">
                 <a:solidFill>
-                  <a:srgbClr val="64748B"/>
-                </a:solidFill>
-              </a:defRPr>
-            </a:pPr>
-            <a:r>
-              <a:t>  10,381 booking records (fully validated)</a:t>
-            </a:r>
-          </a:p>
-          <a:p>
-            <a:pPr>
-              <a:defRPr sz="1200" b="1">
-                <a:solidFill>
-                  <a:srgbClr val="334155"/>
-                </a:solidFill>
-              </a:defRPr>
-            </a:pPr>
-            <a:r>
-              <a:t>• Database Constraint Enforced:</a:t>
-            </a:r>
-          </a:p>
-          <a:p>
-            <a:pPr>
-              <a:spcAft>
-                <a:spcPts val="800"/>
+                  <a:srgbClr val="FFFFFF"/>
+                </a:solidFill>
+                <a:latin typeface="Segoe UI"/>
+              </a:defRPr>
+            </a:pPr>
+            <a:r>
+              <a:t>◆  Clean Output Volume: 10,381 booking records</a:t>
+            </a:r>
+          </a:p>
+          <a:p>
+            <a:pPr>
+              <a:spcAft>
+                <a:spcPts val="1000"/>
               </a:spcAft>
               <a:defRPr sz="1100">
                 <a:solidFill>
-                  <a:srgbClr val="64748B"/>
-                </a:solidFill>
-              </a:defRPr>
-            </a:pPr>
-            <a:r>
-              <a:t>  Travel_Date &gt;= Booking_Date</a:t>
-            </a:r>
-          </a:p>
-          <a:p>
-            <a:pPr>
-              <a:defRPr sz="1200" b="1">
-                <a:solidFill>
-                  <a:srgbClr val="334155"/>
-                </a:solidFill>
-              </a:defRPr>
-            </a:pPr>
-            <a:r>
-              <a:t>• Deduplicated Entries:</a:t>
-            </a:r>
-          </a:p>
-          <a:p>
-            <a:pPr>
-              <a:spcAft>
-                <a:spcPts val="800"/>
+                  <a:srgbClr val="FFFFFF"/>
+                </a:solidFill>
+                <a:latin typeface="Segoe UI"/>
+              </a:defRPr>
+            </a:pPr>
+            <a:r>
+              <a:t>◆  Database Constraint Enforced: Travel_Date &gt;= Booking_Date</a:t>
+            </a:r>
+          </a:p>
+          <a:p>
+            <a:pPr>
+              <a:spcAft>
+                <a:spcPts val="1000"/>
               </a:spcAft>
               <a:defRPr sz="1100">
                 <a:solidFill>
-                  <a:srgbClr val="64748B"/>
-                </a:solidFill>
-              </a:defRPr>
-            </a:pPr>
-            <a:r>
-              <a:t>  Removed 601 exact duplicate booking rows</a:t>
-            </a:r>
-          </a:p>
-          <a:p>
-            <a:pPr>
-              <a:defRPr sz="1200" b="1">
-                <a:solidFill>
-                  <a:srgbClr val="334155"/>
-                </a:solidFill>
-              </a:defRPr>
-            </a:pPr>
-            <a:r>
-              <a:t>• Customer Retention Target:</a:t>
-            </a:r>
-          </a:p>
-          <a:p>
-            <a:pPr>
-              <a:spcAft>
-                <a:spcPts val="800"/>
+                  <a:srgbClr val="FFFFFF"/>
+                </a:solidFill>
+                <a:latin typeface="Segoe UI"/>
+              </a:defRPr>
+            </a:pPr>
+            <a:r>
+              <a:t>◆  Deduplicated Entries: Removed 601 duplicate rows</a:t>
+            </a:r>
+          </a:p>
+          <a:p>
+            <a:pPr>
+              <a:spcAft>
+                <a:spcPts val="1000"/>
               </a:spcAft>
               <a:defRPr sz="1100">
                 <a:solidFill>
-                  <a:srgbClr val="64748B"/>
-                </a:solidFill>
-              </a:defRPr>
-            </a:pPr>
-            <a:r>
-              <a:t>  Cleaned skew lands at 75.0% retention rate</a:t>
+                  <a:srgbClr val="FFFFFF"/>
+                </a:solidFill>
+                <a:latin typeface="Segoe UI"/>
+              </a:defRPr>
+            </a:pPr>
+            <a:r>
+              <a:t>◆  Customer Retention Target: Cleansed at 75.0% rate</a:t>
             </a:r>
           </a:p>
         </p:txBody>
@@ -6193,8 +6918,8 @@
         </p:nvSpPr>
         <p:spPr>
           <a:xfrm>
-            <a:off x="548640" y="457200"/>
-            <a:ext cx="1371600" cy="1097280"/>
+            <a:off x="548640" y="365760"/>
+            <a:ext cx="1371600" cy="822960"/>
           </a:xfrm>
           <a:prstGeom prst="rect">
             <a:avLst/>
@@ -6208,9 +6933,9 @@
           <a:lstStyle/>
           <a:p>
             <a:pPr>
-              <a:defRPr sz="3600" b="1">
-                <a:solidFill>
-                  <a:srgbClr val="4F46E5"/>
+              <a:defRPr sz="3800" b="1">
+                <a:solidFill>
+                  <a:srgbClr val="2563EB"/>
                 </a:solidFill>
                 <a:latin typeface="Segoe UI"/>
               </a:defRPr>
@@ -6229,7 +6954,7 @@
         </p:nvSpPr>
         <p:spPr>
           <a:xfrm>
-            <a:off x="548640" y="1417320"/>
+            <a:off x="548640" y="1280160"/>
             <a:ext cx="3657600" cy="36576"/>
           </a:xfrm>
           <a:prstGeom prst="rect">
@@ -6253,8 +6978,8 @@
         </p:nvSpPr>
         <p:spPr>
           <a:xfrm>
-            <a:off x="548640" y="1554480"/>
-            <a:ext cx="7315200" cy="640080"/>
+            <a:off x="548640" y="1417320"/>
+            <a:ext cx="8229600" cy="640080"/>
           </a:xfrm>
           <a:prstGeom prst="rect">
             <a:avLst/>
@@ -6312,7 +7037,7 @@
               </a:defRPr>
             </a:pPr>
             <a:r>
-              <a:t>6 / 10</a:t>
+              <a:t>6 / 14</a:t>
             </a:r>
           </a:p>
         </p:txBody>
@@ -6342,7 +7067,7 @@
             <a:pPr>
               <a:defRPr sz="1600" b="1">
                 <a:solidFill>
-                  <a:srgbClr val="4F46E5"/>
+                  <a:srgbClr val="2563EB"/>
                 </a:solidFill>
                 <a:latin typeface="Segoe UI"/>
               </a:defRPr>
@@ -6458,33 +7183,50 @@
       </p:sp>
       <p:sp>
         <p:nvSpPr>
-          <p:cNvPr id="8" name="TextBox 7"/>
-          <p:cNvSpPr txBox="1"/>
+          <p:cNvPr id="8" name="Rounded Rectangle 7"/>
+          <p:cNvSpPr/>
           <p:nvPr/>
         </p:nvSpPr>
         <p:spPr>
           <a:xfrm>
             <a:off x="6217920" y="2377440"/>
-            <a:ext cx="5303520" cy="3474720"/>
-          </a:xfrm>
-          <a:prstGeom prst="rect">
-            <a:avLst/>
-          </a:prstGeom>
-          <a:noFill/>
-        </p:spPr>
-        <p:txBody>
-          <a:bodyPr wrap="square">
-            <a:spAutoFit/>
-          </a:bodyPr>
-          <a:lstStyle/>
-          <a:p>
-            <a:pPr>
-              <a:spcAft>
-                <a:spcPts val="1500"/>
-              </a:spcAft>
-              <a:defRPr sz="1500" b="1">
-                <a:solidFill>
-                  <a:srgbClr val="4F46E5"/>
+            <a:ext cx="5303520" cy="3566160"/>
+          </a:xfrm>
+          <a:prstGeom prst="roundRect">
+            <a:avLst/>
+          </a:prstGeom>
+          <a:solidFill>
+            <a:srgbClr val="1A152C"/>
+          </a:solidFill>
+          <a:ln>
+            <a:noFill/>
+          </a:ln>
+        </p:spPr>
+        <p:style>
+          <a:lnRef idx="1">
+            <a:schemeClr val="accent1"/>
+          </a:lnRef>
+          <a:fillRef idx="3">
+            <a:schemeClr val="accent1"/>
+          </a:fillRef>
+          <a:effectRef idx="2">
+            <a:schemeClr val="accent1"/>
+          </a:effectRef>
+          <a:fontRef idx="minor">
+            <a:schemeClr val="lt1"/>
+          </a:fontRef>
+        </p:style>
+        <p:txBody>
+          <a:bodyPr rtlCol="0" anchor="ctr" wrap="square" lIns="228600" tIns="228600" rIns="228600" bIns="228600"/>
+          <a:lstStyle/>
+          <a:p>
+            <a:pPr algn="ctr">
+              <a:spcAft>
+                <a:spcPts val="1400"/>
+              </a:spcAft>
+              <a:defRPr sz="1300" b="1">
+                <a:solidFill>
+                  <a:srgbClr val="EAB308"/>
                 </a:solidFill>
                 <a:latin typeface="Segoe UI"/>
               </a:defRPr>
@@ -6495,41 +7237,18 @@
           </a:p>
           <a:p>
             <a:pPr>
-              <a:defRPr sz="1200" b="1">
-                <a:solidFill>
-                  <a:srgbClr val="334155"/>
-                </a:solidFill>
-              </a:defRPr>
-            </a:pPr>
-            <a:r>
-              <a:t>• Customers (Dimension):</a:t>
-            </a:r>
-          </a:p>
-          <a:p>
-            <a:pPr>
               <a:spcAft>
                 <a:spcPts val="1000"/>
               </a:spcAft>
-              <a:defRPr sz="1050">
-                <a:solidFill>
-                  <a:srgbClr val="64748B"/>
-                </a:solidFill>
-              </a:defRPr>
-            </a:pPr>
-            <a:r>
-              <a:t>  Customer_ID (PK) | Name | Email | Phone | Gender | Age</a:t>
-            </a:r>
-          </a:p>
-          <a:p>
-            <a:pPr>
-              <a:defRPr sz="1200" b="1">
-                <a:solidFill>
-                  <a:srgbClr val="334155"/>
-                </a:solidFill>
-              </a:defRPr>
-            </a:pPr>
-            <a:r>
-              <a:t>• Buses (Dimension):</a:t>
+              <a:defRPr sz="1100">
+                <a:solidFill>
+                  <a:srgbClr val="FFFFFF"/>
+                </a:solidFill>
+                <a:latin typeface="Segoe UI"/>
+              </a:defRPr>
+            </a:pPr>
+            <a:r>
+              <a:t>◆  Customers: Customer_ID (PK) | Name | Email | Phone | Gender | Age</a:t>
             </a:r>
           </a:p>
           <a:p>
@@ -6537,26 +7256,15 @@
               <a:spcAft>
                 <a:spcPts val="1000"/>
               </a:spcAft>
-              <a:defRPr sz="1050">
-                <a:solidFill>
-                  <a:srgbClr val="64748B"/>
-                </a:solidFill>
-              </a:defRPr>
-            </a:pPr>
-            <a:r>
-              <a:t>  Bus_ID (PK) | Bus_Number | Bus_Type | Capacity</a:t>
-            </a:r>
-          </a:p>
-          <a:p>
-            <a:pPr>
-              <a:defRPr sz="1200" b="1">
-                <a:solidFill>
-                  <a:srgbClr val="334155"/>
-                </a:solidFill>
-              </a:defRPr>
-            </a:pPr>
-            <a:r>
-              <a:t>• Routes (Dimension):</a:t>
+              <a:defRPr sz="1100">
+                <a:solidFill>
+                  <a:srgbClr val="FFFFFF"/>
+                </a:solidFill>
+                <a:latin typeface="Segoe UI"/>
+              </a:defRPr>
+            </a:pPr>
+            <a:r>
+              <a:t>◆  Buses: Bus_ID (PK) | Bus_Number | Bus_Type | Capacity</a:t>
             </a:r>
           </a:p>
           <a:p>
@@ -6564,26 +7272,15 @@
               <a:spcAft>
                 <a:spcPts val="1000"/>
               </a:spcAft>
-              <a:defRPr sz="1050">
-                <a:solidFill>
-                  <a:srgbClr val="64748B"/>
-                </a:solidFill>
-              </a:defRPr>
-            </a:pPr>
-            <a:r>
-              <a:t>  Route_ID (PK) | Source | Destination | Distance</a:t>
-            </a:r>
-          </a:p>
-          <a:p>
-            <a:pPr>
-              <a:defRPr sz="1200" b="1">
-                <a:solidFill>
-                  <a:srgbClr val="334155"/>
-                </a:solidFill>
-              </a:defRPr>
-            </a:pPr>
-            <a:r>
-              <a:t>• Bookings (Fact):</a:t>
+              <a:defRPr sz="1100">
+                <a:solidFill>
+                  <a:srgbClr val="FFFFFF"/>
+                </a:solidFill>
+                <a:latin typeface="Segoe UI"/>
+              </a:defRPr>
+            </a:pPr>
+            <a:r>
+              <a:t>◆  Routes: Route_ID (PK) | Source | Destination | Distance</a:t>
             </a:r>
           </a:p>
           <a:p>
@@ -6591,14 +7288,15 @@
               <a:spcAft>
                 <a:spcPts val="1000"/>
               </a:spcAft>
-              <a:defRPr sz="1050">
-                <a:solidFill>
-                  <a:srgbClr val="64748B"/>
-                </a:solidFill>
-              </a:defRPr>
-            </a:pPr>
-            <a:r>
-              <a:t>  Booking_ID (PK) | Customer_ID (FK) | Bus_ID (FK) | Route_ID (FK) | Booking_Date | Travel_Date | Seat_Number | Fare_Amount | Booking_Status</a:t>
+              <a:defRPr sz="1100">
+                <a:solidFill>
+                  <a:srgbClr val="FFFFFF"/>
+                </a:solidFill>
+                <a:latin typeface="Segoe UI"/>
+              </a:defRPr>
+            </a:pPr>
+            <a:r>
+              <a:t>◆  Bookings: Booking_ID (PK) | Customer_ID (FK) | Bus_ID (FK) | Route_ID (FK)</a:t>
             </a:r>
           </a:p>
         </p:txBody>
@@ -6649,8 +7347,8 @@
         </p:nvSpPr>
         <p:spPr>
           <a:xfrm>
-            <a:off x="548640" y="457200"/>
-            <a:ext cx="1371600" cy="1097280"/>
+            <a:off x="548640" y="365760"/>
+            <a:ext cx="1371600" cy="822960"/>
           </a:xfrm>
           <a:prstGeom prst="rect">
             <a:avLst/>
@@ -6664,9 +7362,9 @@
           <a:lstStyle/>
           <a:p>
             <a:pPr>
-              <a:defRPr sz="3600" b="1">
-                <a:solidFill>
-                  <a:srgbClr val="4F46E5"/>
+              <a:defRPr sz="3800" b="1">
+                <a:solidFill>
+                  <a:srgbClr val="2563EB"/>
                 </a:solidFill>
                 <a:latin typeface="Segoe UI"/>
               </a:defRPr>
@@ -6685,7 +7383,7 @@
         </p:nvSpPr>
         <p:spPr>
           <a:xfrm>
-            <a:off x="548640" y="1417320"/>
+            <a:off x="548640" y="1280160"/>
             <a:ext cx="3657600" cy="36576"/>
           </a:xfrm>
           <a:prstGeom prst="rect">
@@ -6709,8 +7407,8 @@
         </p:nvSpPr>
         <p:spPr>
           <a:xfrm>
-            <a:off x="548640" y="1554480"/>
-            <a:ext cx="7315200" cy="640080"/>
+            <a:off x="548640" y="1417320"/>
+            <a:ext cx="8229600" cy="640080"/>
           </a:xfrm>
           <a:prstGeom prst="rect">
             <a:avLst/>
@@ -6732,7 +7430,7 @@
               </a:defRPr>
             </a:pPr>
             <a:r>
-              <a:t>Executive Overview Dashboard</a:t>
+              <a:t>Executive Overview Dashboard (Page 1)</a:t>
             </a:r>
           </a:p>
         </p:txBody>
@@ -6768,7 +7466,7 @@
               </a:defRPr>
             </a:pPr>
             <a:r>
-              <a:t>7 / 10</a:t>
+              <a:t>7 / 14</a:t>
             </a:r>
           </a:p>
         </p:txBody>
@@ -6801,13 +7499,13 @@
               </a:spcAft>
               <a:defRPr sz="1500" b="1">
                 <a:solidFill>
-                  <a:srgbClr val="4F46E5"/>
-                </a:solidFill>
-                <a:latin typeface="Segoe UI"/>
-              </a:defRPr>
-            </a:pPr>
-            <a:r>
-              <a:t>PAGE 1: CORE KPIs &amp; TRENDS</a:t>
+                  <a:srgbClr val="2563EB"/>
+                </a:solidFill>
+                <a:latin typeface="Segoe UI"/>
+              </a:defRPr>
+            </a:pPr>
+            <a:r>
+              <a:t>CORE KPIs &amp; GENERAL DEMANDS</a:t>
             </a:r>
           </a:p>
           <a:p>
@@ -6878,7 +7576,7 @@
       </p:sp>
       <p:pic>
         <p:nvPicPr>
-          <p:cNvPr id="7" name="Picture 6" descr="media__1784141692134.png"/>
+          <p:cNvPr id="7" name="Picture 6" descr="Screenshot 2026-07-16 005206.png"/>
           <p:cNvPicPr>
             <a:picLocks noChangeAspect="1"/>
           </p:cNvPicPr>
@@ -6946,8 +7644,8 @@
         </p:nvSpPr>
         <p:spPr>
           <a:xfrm>
-            <a:off x="548640" y="457200"/>
-            <a:ext cx="1371600" cy="1097280"/>
+            <a:off x="548640" y="365760"/>
+            <a:ext cx="1371600" cy="822960"/>
           </a:xfrm>
           <a:prstGeom prst="rect">
             <a:avLst/>
@@ -6961,9 +7659,9 @@
           <a:lstStyle/>
           <a:p>
             <a:pPr>
-              <a:defRPr sz="3600" b="1">
-                <a:solidFill>
-                  <a:srgbClr val="4F46E5"/>
+              <a:defRPr sz="3800" b="1">
+                <a:solidFill>
+                  <a:srgbClr val="2563EB"/>
                 </a:solidFill>
                 <a:latin typeface="Segoe UI"/>
               </a:defRPr>
@@ -6982,7 +7680,7 @@
         </p:nvSpPr>
         <p:spPr>
           <a:xfrm>
-            <a:off x="548640" y="1417320"/>
+            <a:off x="548640" y="1280160"/>
             <a:ext cx="3657600" cy="36576"/>
           </a:xfrm>
           <a:prstGeom prst="rect">
@@ -7006,8 +7704,8 @@
         </p:nvSpPr>
         <p:spPr>
           <a:xfrm>
-            <a:off x="548640" y="1554480"/>
-            <a:ext cx="7315200" cy="640080"/>
+            <a:off x="548640" y="1417320"/>
+            <a:ext cx="8229600" cy="640080"/>
           </a:xfrm>
           <a:prstGeom prst="rect">
             <a:avLst/>
@@ -7029,7 +7727,7 @@
               </a:defRPr>
             </a:pPr>
             <a:r>
-              <a:t>Operations &amp; Bookings Analysis</a:t>
+              <a:t>Operations &amp; Bookings Analysis (Page 2)</a:t>
             </a:r>
           </a:p>
         </p:txBody>
@@ -7065,7 +7763,7 @@
               </a:defRPr>
             </a:pPr>
             <a:r>
-              <a:t>8 / 10</a:t>
+              <a:t>8 / 14</a:t>
             </a:r>
           </a:p>
         </p:txBody>
@@ -7098,13 +7796,13 @@
               </a:spcAft>
               <a:defRPr sz="1500" b="1">
                 <a:solidFill>
-                  <a:srgbClr val="4F46E5"/>
-                </a:solidFill>
-                <a:latin typeface="Segoe UI"/>
-              </a:defRPr>
-            </a:pPr>
-            <a:r>
-              <a:t>PAGE 2: DEMAND &amp; VERIFICATION</a:t>
+                  <a:srgbClr val="2563EB"/>
+                </a:solidFill>
+                <a:latin typeface="Segoe UI"/>
+              </a:defRPr>
+            </a:pPr>
+            <a:r>
+              <a:t>DEMAND &amp; VERIFICATION RATIOS</a:t>
             </a:r>
           </a:p>
           <a:p>
@@ -7175,7 +7873,7 @@
       </p:sp>
       <p:pic>
         <p:nvPicPr>
-          <p:cNvPr id="7" name="Picture 6" descr="media__1784141725211.png"/>
+          <p:cNvPr id="7" name="Picture 6" descr="Screenshot 2026-07-16 005249.png"/>
           <p:cNvPicPr>
             <a:picLocks noChangeAspect="1"/>
           </p:cNvPicPr>
@@ -7243,8 +7941,8 @@
         </p:nvSpPr>
         <p:spPr>
           <a:xfrm>
-            <a:off x="548640" y="457200"/>
-            <a:ext cx="1371600" cy="1097280"/>
+            <a:off x="548640" y="365760"/>
+            <a:ext cx="1371600" cy="822960"/>
           </a:xfrm>
           <a:prstGeom prst="rect">
             <a:avLst/>
@@ -7258,9 +7956,9 @@
           <a:lstStyle/>
           <a:p>
             <a:pPr>
-              <a:defRPr sz="3600" b="1">
-                <a:solidFill>
-                  <a:srgbClr val="4F46E5"/>
+              <a:defRPr sz="3800" b="1">
+                <a:solidFill>
+                  <a:srgbClr val="2563EB"/>
                 </a:solidFill>
                 <a:latin typeface="Segoe UI"/>
               </a:defRPr>
@@ -7279,7 +7977,7 @@
         </p:nvSpPr>
         <p:spPr>
           <a:xfrm>
-            <a:off x="548640" y="1417320"/>
+            <a:off x="548640" y="1280160"/>
             <a:ext cx="3657600" cy="36576"/>
           </a:xfrm>
           <a:prstGeom prst="rect">
@@ -7303,8 +8001,8 @@
         </p:nvSpPr>
         <p:spPr>
           <a:xfrm>
-            <a:off x="548640" y="1554480"/>
-            <a:ext cx="7315200" cy="640080"/>
+            <a:off x="548640" y="1417320"/>
+            <a:ext cx="8229600" cy="640080"/>
           </a:xfrm>
           <a:prstGeom prst="rect">
             <a:avLst/>
@@ -7326,7 +8024,7 @@
               </a:defRPr>
             </a:pPr>
             <a:r>
-              <a:t>Revenue &amp; Yield Optimization</a:t>
+              <a:t>Revenue &amp; Yield Optimization (Page 3)</a:t>
             </a:r>
           </a:p>
         </p:txBody>
@@ -7362,7 +8060,7 @@
               </a:defRPr>
             </a:pPr>
             <a:r>
-              <a:t>9 / 10</a:t>
+              <a:t>9 / 14</a:t>
             </a:r>
           </a:p>
         </p:txBody>
@@ -7395,13 +8093,13 @@
               </a:spcAft>
               <a:defRPr sz="1500" b="1">
                 <a:solidFill>
-                  <a:srgbClr val="4F46E5"/>
-                </a:solidFill>
-                <a:latin typeface="Segoe UI"/>
-              </a:defRPr>
-            </a:pPr>
-            <a:r>
-              <a:t>PAGE 3: FINANCIAL YIELD CORRIDORS</a:t>
+                  <a:srgbClr val="2563EB"/>
+                </a:solidFill>
+                <a:latin typeface="Segoe UI"/>
+              </a:defRPr>
+            </a:pPr>
+            <a:r>
+              <a:t>FINANCIAL YIELD CORRIDORS</a:t>
             </a:r>
           </a:p>
           <a:p>
@@ -7472,7 +8170,7 @@
       </p:sp>
       <p:pic>
         <p:nvPicPr>
-          <p:cNvPr id="7" name="Picture 6" descr="media__1784141745466.png"/>
+          <p:cNvPr id="7" name="Picture 6" descr="Screenshot 2026-07-16 005307.png"/>
           <p:cNvPicPr>
             <a:picLocks noChangeAspect="1"/>
           </p:cNvPicPr>

</xml_diff>

<commit_message>
docs: recolor slides to palette #054A75, #06B6D4, #64748B, center layouts, and add team names
</commit_message>
<xml_diff>
--- a/Bus Booking Analytics System (PowerBI)/documents/Bus_Booking_Analytics_PowerBI_light.pptx
+++ b/Bus Booking Analytics System (PowerBI)/documents/Bus_Booking_Analytics_PowerBI_light.pptx
@@ -3135,7 +3135,7 @@
             <a:pPr>
               <a:defRPr sz="1400" b="1">
                 <a:solidFill>
-                  <a:srgbClr val="2563EB"/>
+                  <a:srgbClr val="06B6D4"/>
                 </a:solidFill>
                 <a:latin typeface="Segoe UI"/>
               </a:defRPr>
@@ -3171,7 +3171,7 @@
             <a:pPr>
               <a:defRPr sz="4000" b="1">
                 <a:solidFill>
-                  <a:srgbClr val="0F172A"/>
+                  <a:srgbClr val="054A75"/>
                 </a:solidFill>
                 <a:latin typeface="Segoe UI"/>
               </a:defRPr>
@@ -3249,7 +3249,7 @@
               </a:defRPr>
             </a:pPr>
             <a:r>
-              <a:t>Submitted by: Gururaj Shetty  |  Revature Data Analytics Phase 2</a:t>
+              <a:t>Submitted by: Harish, Harini, Gururaj Shetty  |  Revature Data Analytics Phase 2</a:t>
             </a:r>
             <a:br/>
             <a:r>
@@ -3321,7 +3321,7 @@
             <a:pPr>
               <a:defRPr sz="3800" b="1">
                 <a:solidFill>
-                  <a:srgbClr val="2563EB"/>
+                  <a:srgbClr val="06B6D4"/>
                 </a:solidFill>
                 <a:latin typeface="Segoe UI"/>
               </a:defRPr>
@@ -3381,7 +3381,7 @@
             <a:pPr>
               <a:defRPr sz="2400" b="1">
                 <a:solidFill>
-                  <a:srgbClr val="0F172A"/>
+                  <a:srgbClr val="054A75"/>
                 </a:solidFill>
                 <a:latin typeface="Segoe UI"/>
               </a:defRPr>
@@ -3436,7 +3436,7 @@
         </p:nvSpPr>
         <p:spPr>
           <a:xfrm>
-            <a:off x="548640" y="2377440"/>
+            <a:off x="557784" y="2377440"/>
             <a:ext cx="5303520" cy="3657600"/>
           </a:xfrm>
           <a:prstGeom prst="rect">
@@ -3456,7 +3456,7 @@
               </a:spcAft>
               <a:defRPr sz="1500" b="1">
                 <a:solidFill>
-                  <a:srgbClr val="2563EB"/>
+                  <a:srgbClr val="06B6D4"/>
                 </a:solidFill>
                 <a:latin typeface="Segoe UI"/>
               </a:defRPr>
@@ -3547,8 +3547,8 @@
         </p:blipFill>
         <p:spPr>
           <a:xfrm>
-            <a:off x="6217920" y="2286000"/>
-            <a:ext cx="5394960" cy="3035808"/>
+            <a:off x="6409944" y="2286000"/>
+            <a:ext cx="5212080" cy="2926080"/>
           </a:xfrm>
           <a:prstGeom prst="rect">
             <a:avLst/>
@@ -3618,7 +3618,7 @@
             <a:pPr>
               <a:defRPr sz="3800" b="1">
                 <a:solidFill>
-                  <a:srgbClr val="2563EB"/>
+                  <a:srgbClr val="06B6D4"/>
                 </a:solidFill>
                 <a:latin typeface="Segoe UI"/>
               </a:defRPr>
@@ -3678,7 +3678,7 @@
             <a:pPr>
               <a:defRPr sz="2400" b="1">
                 <a:solidFill>
-                  <a:srgbClr val="0F172A"/>
+                  <a:srgbClr val="054A75"/>
                 </a:solidFill>
                 <a:latin typeface="Segoe UI"/>
               </a:defRPr>
@@ -3733,7 +3733,7 @@
         </p:nvSpPr>
         <p:spPr>
           <a:xfrm>
-            <a:off x="548640" y="2377440"/>
+            <a:off x="557784" y="2377440"/>
             <a:ext cx="5303520" cy="3657600"/>
           </a:xfrm>
           <a:prstGeom prst="rect">
@@ -3753,7 +3753,7 @@
               </a:spcAft>
               <a:defRPr sz="1500" b="1">
                 <a:solidFill>
-                  <a:srgbClr val="2563EB"/>
+                  <a:srgbClr val="06B6D4"/>
                 </a:solidFill>
                 <a:latin typeface="Segoe UI"/>
               </a:defRPr>
@@ -3844,8 +3844,8 @@
         </p:blipFill>
         <p:spPr>
           <a:xfrm>
-            <a:off x="6217920" y="2286000"/>
-            <a:ext cx="5394960" cy="3035808"/>
+            <a:off x="6409944" y="2286000"/>
+            <a:ext cx="5212080" cy="2926080"/>
           </a:xfrm>
           <a:prstGeom prst="rect">
             <a:avLst/>
@@ -3915,7 +3915,7 @@
             <a:pPr>
               <a:defRPr sz="3800" b="1">
                 <a:solidFill>
-                  <a:srgbClr val="2563EB"/>
+                  <a:srgbClr val="06B6D4"/>
                 </a:solidFill>
                 <a:latin typeface="Segoe UI"/>
               </a:defRPr>
@@ -3975,7 +3975,7 @@
             <a:pPr>
               <a:defRPr sz="2400" b="1">
                 <a:solidFill>
-                  <a:srgbClr val="0F172A"/>
+                  <a:srgbClr val="054A75"/>
                 </a:solidFill>
                 <a:latin typeface="Segoe UI"/>
               </a:defRPr>
@@ -4030,7 +4030,7 @@
         </p:nvSpPr>
         <p:spPr>
           <a:xfrm>
-            <a:off x="548640" y="2377440"/>
+            <a:off x="557784" y="2377440"/>
             <a:ext cx="5303520" cy="3657600"/>
           </a:xfrm>
           <a:prstGeom prst="rect">
@@ -4050,7 +4050,7 @@
               </a:spcAft>
               <a:defRPr sz="1500" b="1">
                 <a:solidFill>
-                  <a:srgbClr val="2563EB"/>
+                  <a:srgbClr val="06B6D4"/>
                 </a:solidFill>
                 <a:latin typeface="Segoe UI"/>
               </a:defRPr>
@@ -4141,8 +4141,8 @@
         </p:blipFill>
         <p:spPr>
           <a:xfrm>
-            <a:off x="6217920" y="2286000"/>
-            <a:ext cx="5394960" cy="3035808"/>
+            <a:off x="6409944" y="2286000"/>
+            <a:ext cx="5212080" cy="2926080"/>
           </a:xfrm>
           <a:prstGeom prst="rect">
             <a:avLst/>
@@ -4212,7 +4212,7 @@
             <a:pPr>
               <a:defRPr sz="3800" b="1">
                 <a:solidFill>
-                  <a:srgbClr val="2563EB"/>
+                  <a:srgbClr val="06B6D4"/>
                 </a:solidFill>
                 <a:latin typeface="Segoe UI"/>
               </a:defRPr>
@@ -4272,7 +4272,7 @@
             <a:pPr>
               <a:defRPr sz="2400" b="1">
                 <a:solidFill>
-                  <a:srgbClr val="0F172A"/>
+                  <a:srgbClr val="054A75"/>
                 </a:solidFill>
                 <a:latin typeface="Segoe UI"/>
               </a:defRPr>
@@ -4327,7 +4327,7 @@
         </p:nvSpPr>
         <p:spPr>
           <a:xfrm>
-            <a:off x="548640" y="2377440"/>
+            <a:off x="557784" y="2377440"/>
             <a:ext cx="5303520" cy="3657600"/>
           </a:xfrm>
           <a:prstGeom prst="rect">
@@ -4347,7 +4347,7 @@
               </a:spcAft>
               <a:defRPr sz="1500" b="1">
                 <a:solidFill>
-                  <a:srgbClr val="2563EB"/>
+                  <a:srgbClr val="06B6D4"/>
                 </a:solidFill>
                 <a:latin typeface="Segoe UI"/>
               </a:defRPr>
@@ -4438,8 +4438,8 @@
         </p:blipFill>
         <p:spPr>
           <a:xfrm>
-            <a:off x="6217920" y="2286000"/>
-            <a:ext cx="5394960" cy="3035808"/>
+            <a:off x="6409944" y="2286000"/>
+            <a:ext cx="5212080" cy="2926080"/>
           </a:xfrm>
           <a:prstGeom prst="rect">
             <a:avLst/>
@@ -4509,7 +4509,7 @@
             <a:pPr>
               <a:defRPr sz="3800" b="1">
                 <a:solidFill>
-                  <a:srgbClr val="2563EB"/>
+                  <a:srgbClr val="06B6D4"/>
                 </a:solidFill>
                 <a:latin typeface="Segoe UI"/>
               </a:defRPr>
@@ -4569,7 +4569,7 @@
             <a:pPr>
               <a:defRPr sz="2400" b="1">
                 <a:solidFill>
-                  <a:srgbClr val="0F172A"/>
+                  <a:srgbClr val="054A75"/>
                 </a:solidFill>
                 <a:latin typeface="Segoe UI"/>
               </a:defRPr>
@@ -4624,8 +4624,8 @@
         </p:nvSpPr>
         <p:spPr>
           <a:xfrm>
-            <a:off x="457200" y="2377440"/>
-            <a:ext cx="5303520" cy="1645920"/>
+            <a:off x="694944" y="2377440"/>
+            <a:ext cx="5120640" cy="1645920"/>
           </a:xfrm>
           <a:prstGeom prst="roundRect">
             <a:avLst/>
@@ -4661,7 +4661,7 @@
               </a:spcAft>
               <a:defRPr sz="1300" b="1">
                 <a:solidFill>
-                  <a:srgbClr val="2563EB"/>
+                  <a:srgbClr val="06B6D4"/>
                 </a:solidFill>
                 <a:latin typeface="Segoe UI"/>
               </a:defRPr>
@@ -4696,8 +4696,8 @@
         </p:nvSpPr>
         <p:spPr>
           <a:xfrm>
-            <a:off x="6217920" y="2377440"/>
-            <a:ext cx="5303520" cy="1645920"/>
+            <a:off x="6364224" y="2377440"/>
+            <a:ext cx="5120640" cy="1645920"/>
           </a:xfrm>
           <a:prstGeom prst="roundRect">
             <a:avLst/>
@@ -4733,7 +4733,7 @@
               </a:spcAft>
               <a:defRPr sz="1300" b="1">
                 <a:solidFill>
-                  <a:srgbClr val="2563EB"/>
+                  <a:srgbClr val="06B6D4"/>
                 </a:solidFill>
                 <a:latin typeface="Segoe UI"/>
               </a:defRPr>
@@ -4768,8 +4768,8 @@
         </p:nvSpPr>
         <p:spPr>
           <a:xfrm>
-            <a:off x="457200" y="4297680"/>
-            <a:ext cx="5303520" cy="1645920"/>
+            <a:off x="694944" y="4297680"/>
+            <a:ext cx="5120640" cy="1645920"/>
           </a:xfrm>
           <a:prstGeom prst="roundRect">
             <a:avLst/>
@@ -4805,7 +4805,7 @@
               </a:spcAft>
               <a:defRPr sz="1300" b="1">
                 <a:solidFill>
-                  <a:srgbClr val="2563EB"/>
+                  <a:srgbClr val="06B6D4"/>
                 </a:solidFill>
                 <a:latin typeface="Segoe UI"/>
               </a:defRPr>
@@ -4840,8 +4840,8 @@
         </p:nvSpPr>
         <p:spPr>
           <a:xfrm>
-            <a:off x="6217920" y="4297680"/>
-            <a:ext cx="5303520" cy="1645920"/>
+            <a:off x="6364224" y="4297680"/>
+            <a:ext cx="5120640" cy="1645920"/>
           </a:xfrm>
           <a:prstGeom prst="roundRect">
             <a:avLst/>
@@ -4877,7 +4877,7 @@
               </a:spcAft>
               <a:defRPr sz="1300" b="1">
                 <a:solidFill>
-                  <a:srgbClr val="2563EB"/>
+                  <a:srgbClr val="06B6D4"/>
                 </a:solidFill>
                 <a:latin typeface="Segoe UI"/>
               </a:defRPr>
@@ -4967,7 +4967,7 @@
             <a:pPr algn="ctr">
               <a:defRPr sz="4800" b="1">
                 <a:solidFill>
-                  <a:srgbClr val="2563EB"/>
+                  <a:srgbClr val="06B6D4"/>
                 </a:solidFill>
                 <a:latin typeface="Segoe UI"/>
               </a:defRPr>
@@ -5003,7 +5003,7 @@
             <a:pPr algn="ctr">
               <a:defRPr sz="1600" b="1">
                 <a:solidFill>
-                  <a:srgbClr val="0F172A"/>
+                  <a:srgbClr val="054A75"/>
                 </a:solidFill>
                 <a:latin typeface="Segoe UI"/>
               </a:defRPr>
@@ -5045,7 +5045,7 @@
               </a:defRPr>
             </a:pPr>
             <a:r>
-              <a:t>Gururaj Shetty  |  Revature Data Analytics</a:t>
+              <a:t>Harish, Harini, Gururaj Shetty  |  Revature Data Analytics</a:t>
             </a:r>
             <a:br/>
             <a:r>
@@ -5117,7 +5117,7 @@
             <a:pPr>
               <a:defRPr sz="3800" b="1">
                 <a:solidFill>
-                  <a:srgbClr val="2563EB"/>
+                  <a:srgbClr val="06B6D4"/>
                 </a:solidFill>
                 <a:latin typeface="Segoe UI"/>
               </a:defRPr>
@@ -5177,7 +5177,7 @@
             <a:pPr>
               <a:defRPr sz="2400" b="1">
                 <a:solidFill>
-                  <a:srgbClr val="0F172A"/>
+                  <a:srgbClr val="054A75"/>
                 </a:solidFill>
                 <a:latin typeface="Segoe UI"/>
               </a:defRPr>
@@ -5422,7 +5422,7 @@
             <a:pPr>
               <a:defRPr sz="3800" b="1">
                 <a:solidFill>
-                  <a:srgbClr val="2563EB"/>
+                  <a:srgbClr val="06B6D4"/>
                 </a:solidFill>
                 <a:latin typeface="Segoe UI"/>
               </a:defRPr>
@@ -5482,7 +5482,7 @@
             <a:pPr>
               <a:defRPr sz="2400" b="1">
                 <a:solidFill>
-                  <a:srgbClr val="0F172A"/>
+                  <a:srgbClr val="054A75"/>
                 </a:solidFill>
                 <a:latin typeface="Segoe UI"/>
               </a:defRPr>
@@ -5537,7 +5537,7 @@
         </p:nvSpPr>
         <p:spPr>
           <a:xfrm>
-            <a:off x="548640" y="2468880"/>
+            <a:off x="877824" y="2468880"/>
             <a:ext cx="3474720" cy="3657600"/>
           </a:xfrm>
           <a:prstGeom prst="roundRect">
@@ -5641,7 +5641,7 @@
         </p:nvSpPr>
         <p:spPr>
           <a:xfrm>
-            <a:off x="4297680" y="2468880"/>
+            <a:off x="4626864" y="2468880"/>
             <a:ext cx="3474720" cy="3657600"/>
           </a:xfrm>
           <a:prstGeom prst="roundRect">
@@ -5745,7 +5745,7 @@
         </p:nvSpPr>
         <p:spPr>
           <a:xfrm>
-            <a:off x="8046720" y="2468880"/>
+            <a:off x="8375904" y="2468880"/>
             <a:ext cx="3474720" cy="3657600"/>
           </a:xfrm>
           <a:prstGeom prst="roundRect">
@@ -5904,7 +5904,7 @@
             <a:pPr>
               <a:defRPr sz="3800" b="1">
                 <a:solidFill>
-                  <a:srgbClr val="2563EB"/>
+                  <a:srgbClr val="06B6D4"/>
                 </a:solidFill>
                 <a:latin typeface="Segoe UI"/>
               </a:defRPr>
@@ -5964,7 +5964,7 @@
             <a:pPr>
               <a:defRPr sz="2400" b="1">
                 <a:solidFill>
-                  <a:srgbClr val="0F172A"/>
+                  <a:srgbClr val="054A75"/>
                 </a:solidFill>
                 <a:latin typeface="Segoe UI"/>
               </a:defRPr>
@@ -6019,7 +6019,7 @@
         </p:nvSpPr>
         <p:spPr>
           <a:xfrm>
-            <a:off x="548640" y="2560320"/>
+            <a:off x="969264" y="2560320"/>
             <a:ext cx="2560320" cy="3383280"/>
           </a:xfrm>
           <a:prstGeom prst="roundRect">
@@ -6056,7 +6056,7 @@
               </a:spcAft>
               <a:defRPr sz="1300" b="1">
                 <a:solidFill>
-                  <a:srgbClr val="2563EB"/>
+                  <a:srgbClr val="06B6D4"/>
                 </a:solidFill>
                 <a:latin typeface="Segoe UI"/>
               </a:defRPr>
@@ -6123,7 +6123,7 @@
         </p:nvSpPr>
         <p:spPr>
           <a:xfrm>
-            <a:off x="3383280" y="2560320"/>
+            <a:off x="3803904" y="2560320"/>
             <a:ext cx="2560320" cy="3383280"/>
           </a:xfrm>
           <a:prstGeom prst="roundRect">
@@ -6160,7 +6160,7 @@
               </a:spcAft>
               <a:defRPr sz="1300" b="1">
                 <a:solidFill>
-                  <a:srgbClr val="2563EB"/>
+                  <a:srgbClr val="06B6D4"/>
                 </a:solidFill>
                 <a:latin typeface="Segoe UI"/>
               </a:defRPr>
@@ -6227,7 +6227,7 @@
         </p:nvSpPr>
         <p:spPr>
           <a:xfrm>
-            <a:off x="6217920" y="2560320"/>
+            <a:off x="6638544" y="2560320"/>
             <a:ext cx="2560320" cy="3383280"/>
           </a:xfrm>
           <a:prstGeom prst="roundRect">
@@ -6264,7 +6264,7 @@
               </a:spcAft>
               <a:defRPr sz="1300" b="1">
                 <a:solidFill>
-                  <a:srgbClr val="2563EB"/>
+                  <a:srgbClr val="06B6D4"/>
                 </a:solidFill>
                 <a:latin typeface="Segoe UI"/>
               </a:defRPr>
@@ -6331,7 +6331,7 @@
         </p:nvSpPr>
         <p:spPr>
           <a:xfrm>
-            <a:off x="9052560" y="2560320"/>
+            <a:off x="9473184" y="2560320"/>
             <a:ext cx="2560320" cy="3383280"/>
           </a:xfrm>
           <a:prstGeom prst="roundRect">
@@ -6368,7 +6368,7 @@
               </a:spcAft>
               <a:defRPr sz="1300" b="1">
                 <a:solidFill>
-                  <a:srgbClr val="2563EB"/>
+                  <a:srgbClr val="06B6D4"/>
                 </a:solidFill>
                 <a:latin typeface="Segoe UI"/>
               </a:defRPr>
@@ -6490,7 +6490,7 @@
             <a:pPr>
               <a:defRPr sz="3800" b="1">
                 <a:solidFill>
-                  <a:srgbClr val="2563EB"/>
+                  <a:srgbClr val="06B6D4"/>
                 </a:solidFill>
                 <a:latin typeface="Segoe UI"/>
               </a:defRPr>
@@ -6550,7 +6550,7 @@
             <a:pPr>
               <a:defRPr sz="2400" b="1">
                 <a:solidFill>
-                  <a:srgbClr val="0F172A"/>
+                  <a:srgbClr val="054A75"/>
                 </a:solidFill>
                 <a:latin typeface="Segoe UI"/>
               </a:defRPr>
@@ -6605,7 +6605,7 @@
         </p:nvSpPr>
         <p:spPr>
           <a:xfrm>
-            <a:off x="548640" y="2377440"/>
+            <a:off x="557784" y="2377440"/>
             <a:ext cx="5303520" cy="457200"/>
           </a:xfrm>
           <a:prstGeom prst="rect">
@@ -6622,7 +6622,7 @@
             <a:pPr>
               <a:defRPr sz="1600" b="1">
                 <a:solidFill>
-                  <a:srgbClr val="2563EB"/>
+                  <a:srgbClr val="06B6D4"/>
                 </a:solidFill>
                 <a:latin typeface="Segoe UI"/>
               </a:defRPr>
@@ -6641,7 +6641,7 @@
         </p:nvSpPr>
         <p:spPr>
           <a:xfrm>
-            <a:off x="548640" y="2926080"/>
+            <a:off x="557784" y="2926080"/>
             <a:ext cx="5303520" cy="3200400"/>
           </a:xfrm>
           <a:prstGeom prst="rect">
@@ -6744,8 +6744,8 @@
         </p:nvSpPr>
         <p:spPr>
           <a:xfrm>
-            <a:off x="6217920" y="2377440"/>
-            <a:ext cx="5303520" cy="3566160"/>
+            <a:off x="6409944" y="2377440"/>
+            <a:ext cx="5212080" cy="3566160"/>
           </a:xfrm>
           <a:prstGeom prst="roundRect">
             <a:avLst/>
@@ -6935,7 +6935,7 @@
             <a:pPr>
               <a:defRPr sz="3800" b="1">
                 <a:solidFill>
-                  <a:srgbClr val="2563EB"/>
+                  <a:srgbClr val="06B6D4"/>
                 </a:solidFill>
                 <a:latin typeface="Segoe UI"/>
               </a:defRPr>
@@ -6995,7 +6995,7 @@
             <a:pPr>
               <a:defRPr sz="2400" b="1">
                 <a:solidFill>
-                  <a:srgbClr val="0F172A"/>
+                  <a:srgbClr val="054A75"/>
                 </a:solidFill>
                 <a:latin typeface="Segoe UI"/>
               </a:defRPr>
@@ -7050,7 +7050,7 @@
         </p:nvSpPr>
         <p:spPr>
           <a:xfrm>
-            <a:off x="548640" y="2377440"/>
+            <a:off x="557784" y="2377440"/>
             <a:ext cx="5303520" cy="457200"/>
           </a:xfrm>
           <a:prstGeom prst="rect">
@@ -7067,7 +7067,7 @@
             <a:pPr>
               <a:defRPr sz="1600" b="1">
                 <a:solidFill>
-                  <a:srgbClr val="2563EB"/>
+                  <a:srgbClr val="06B6D4"/>
                 </a:solidFill>
                 <a:latin typeface="Segoe UI"/>
               </a:defRPr>
@@ -7086,7 +7086,7 @@
         </p:nvSpPr>
         <p:spPr>
           <a:xfrm>
-            <a:off x="548640" y="2926080"/>
+            <a:off x="557784" y="2926080"/>
             <a:ext cx="5303520" cy="3200400"/>
           </a:xfrm>
           <a:prstGeom prst="rect">
@@ -7189,8 +7189,8 @@
         </p:nvSpPr>
         <p:spPr>
           <a:xfrm>
-            <a:off x="6217920" y="2377440"/>
-            <a:ext cx="5303520" cy="3566160"/>
+            <a:off x="6409944" y="2377440"/>
+            <a:ext cx="5212080" cy="3566160"/>
           </a:xfrm>
           <a:prstGeom prst="roundRect">
             <a:avLst/>
@@ -7226,7 +7226,7 @@
               </a:spcAft>
               <a:defRPr sz="1300" b="1">
                 <a:solidFill>
-                  <a:srgbClr val="EAB308"/>
+                  <a:srgbClr val="06B6D4"/>
                 </a:solidFill>
                 <a:latin typeface="Segoe UI"/>
               </a:defRPr>
@@ -7364,7 +7364,7 @@
             <a:pPr>
               <a:defRPr sz="3800" b="1">
                 <a:solidFill>
-                  <a:srgbClr val="2563EB"/>
+                  <a:srgbClr val="06B6D4"/>
                 </a:solidFill>
                 <a:latin typeface="Segoe UI"/>
               </a:defRPr>
@@ -7424,7 +7424,7 @@
             <a:pPr>
               <a:defRPr sz="2400" b="1">
                 <a:solidFill>
-                  <a:srgbClr val="0F172A"/>
+                  <a:srgbClr val="054A75"/>
                 </a:solidFill>
                 <a:latin typeface="Segoe UI"/>
               </a:defRPr>
@@ -7479,7 +7479,7 @@
         </p:nvSpPr>
         <p:spPr>
           <a:xfrm>
-            <a:off x="548640" y="2377440"/>
+            <a:off x="557784" y="2377440"/>
             <a:ext cx="5303520" cy="3657600"/>
           </a:xfrm>
           <a:prstGeom prst="rect">
@@ -7499,7 +7499,7 @@
               </a:spcAft>
               <a:defRPr sz="1500" b="1">
                 <a:solidFill>
-                  <a:srgbClr val="2563EB"/>
+                  <a:srgbClr val="06B6D4"/>
                 </a:solidFill>
                 <a:latin typeface="Segoe UI"/>
               </a:defRPr>
@@ -7590,8 +7590,8 @@
         </p:blipFill>
         <p:spPr>
           <a:xfrm>
-            <a:off x="6217920" y="2286000"/>
-            <a:ext cx="5394960" cy="3035808"/>
+            <a:off x="6409944" y="2286000"/>
+            <a:ext cx="5212080" cy="2926080"/>
           </a:xfrm>
           <a:prstGeom prst="rect">
             <a:avLst/>
@@ -7661,7 +7661,7 @@
             <a:pPr>
               <a:defRPr sz="3800" b="1">
                 <a:solidFill>
-                  <a:srgbClr val="2563EB"/>
+                  <a:srgbClr val="06B6D4"/>
                 </a:solidFill>
                 <a:latin typeface="Segoe UI"/>
               </a:defRPr>
@@ -7721,7 +7721,7 @@
             <a:pPr>
               <a:defRPr sz="2400" b="1">
                 <a:solidFill>
-                  <a:srgbClr val="0F172A"/>
+                  <a:srgbClr val="054A75"/>
                 </a:solidFill>
                 <a:latin typeface="Segoe UI"/>
               </a:defRPr>
@@ -7776,7 +7776,7 @@
         </p:nvSpPr>
         <p:spPr>
           <a:xfrm>
-            <a:off x="548640" y="2377440"/>
+            <a:off x="557784" y="2377440"/>
             <a:ext cx="5303520" cy="3657600"/>
           </a:xfrm>
           <a:prstGeom prst="rect">
@@ -7796,7 +7796,7 @@
               </a:spcAft>
               <a:defRPr sz="1500" b="1">
                 <a:solidFill>
-                  <a:srgbClr val="2563EB"/>
+                  <a:srgbClr val="06B6D4"/>
                 </a:solidFill>
                 <a:latin typeface="Segoe UI"/>
               </a:defRPr>
@@ -7887,8 +7887,8 @@
         </p:blipFill>
         <p:spPr>
           <a:xfrm>
-            <a:off x="6217920" y="2286000"/>
-            <a:ext cx="5394960" cy="3035808"/>
+            <a:off x="6409944" y="2286000"/>
+            <a:ext cx="5212080" cy="2926080"/>
           </a:xfrm>
           <a:prstGeom prst="rect">
             <a:avLst/>
@@ -7958,7 +7958,7 @@
             <a:pPr>
               <a:defRPr sz="3800" b="1">
                 <a:solidFill>
-                  <a:srgbClr val="2563EB"/>
+                  <a:srgbClr val="06B6D4"/>
                 </a:solidFill>
                 <a:latin typeface="Segoe UI"/>
               </a:defRPr>
@@ -8018,7 +8018,7 @@
             <a:pPr>
               <a:defRPr sz="2400" b="1">
                 <a:solidFill>
-                  <a:srgbClr val="0F172A"/>
+                  <a:srgbClr val="054A75"/>
                 </a:solidFill>
                 <a:latin typeface="Segoe UI"/>
               </a:defRPr>
@@ -8073,7 +8073,7 @@
         </p:nvSpPr>
         <p:spPr>
           <a:xfrm>
-            <a:off x="548640" y="2377440"/>
+            <a:off x="557784" y="2377440"/>
             <a:ext cx="5303520" cy="3657600"/>
           </a:xfrm>
           <a:prstGeom prst="rect">
@@ -8093,7 +8093,7 @@
               </a:spcAft>
               <a:defRPr sz="1500" b="1">
                 <a:solidFill>
-                  <a:srgbClr val="2563EB"/>
+                  <a:srgbClr val="06B6D4"/>
                 </a:solidFill>
                 <a:latin typeface="Segoe UI"/>
               </a:defRPr>
@@ -8184,8 +8184,8 @@
         </p:blipFill>
         <p:spPr>
           <a:xfrm>
-            <a:off x="6217920" y="2286000"/>
-            <a:ext cx="5394960" cy="3035808"/>
+            <a:off x="6409944" y="2286000"/>
+            <a:ext cx="5212080" cy="2926080"/>
           </a:xfrm>
           <a:prstGeom prst="rect">
             <a:avLst/>

</xml_diff>